<commit_message>
added shows of bias
</commit_message>
<xml_diff>
--- a/Presentations/Presentation_11_18_25.pptx
+++ b/Presentations/Presentation_11_18_25.pptx
@@ -5,20 +5,21 @@
     <p:sldMasterId id="2147483648" r:id="rId1"/>
   </p:sldMasterIdLst>
   <p:notesMasterIdLst>
-    <p:notesMasterId r:id="rId13"/>
+    <p:notesMasterId r:id="rId14"/>
   </p:notesMasterIdLst>
   <p:sldIdLst>
     <p:sldId id="256" r:id="rId2"/>
     <p:sldId id="257" r:id="rId3"/>
-    <p:sldId id="260" r:id="rId4"/>
-    <p:sldId id="261" r:id="rId5"/>
-    <p:sldId id="259" r:id="rId6"/>
+    <p:sldId id="261" r:id="rId4"/>
+    <p:sldId id="259" r:id="rId5"/>
+    <p:sldId id="268" r:id="rId6"/>
     <p:sldId id="262" r:id="rId7"/>
     <p:sldId id="263" r:id="rId8"/>
-    <p:sldId id="267" r:id="rId9"/>
-    <p:sldId id="264" r:id="rId10"/>
-    <p:sldId id="266" r:id="rId11"/>
-    <p:sldId id="265" r:id="rId12"/>
+    <p:sldId id="269" r:id="rId9"/>
+    <p:sldId id="270" r:id="rId10"/>
+    <p:sldId id="264" r:id="rId11"/>
+    <p:sldId id="266" r:id="rId12"/>
+    <p:sldId id="265" r:id="rId13"/>
   </p:sldIdLst>
   <p:sldSz cx="12192000" cy="6858000"/>
   <p:notesSz cx="6858000" cy="9144000"/>
@@ -117,6 +118,11 @@
       </a:defRPr>
     </a:lvl9pPr>
   </p:defaultTextStyle>
+  <p:extLst>
+    <p:ext uri="{EFAFB233-063F-42B5-8137-9DF3F51BA10A}">
+      <p15:sldGuideLst xmlns:p15="http://schemas.microsoft.com/office/powerpoint/2012/main"/>
+    </p:ext>
+  </p:extLst>
 </p:presentation>
 </file>
 
@@ -202,7 +208,7 @@
           <a:p>
             <a:fld id="{889B35F2-97E0-4A15-9BF5-D9D4D1862800}" type="datetimeFigureOut">
               <a:rPr lang="en-US" smtClean="0"/>
-              <a:t>11/18/2025</a:t>
+              <a:t>11/25/2025</a:t>
             </a:fld>
             <a:endParaRPr lang="en-US"/>
           </a:p>
@@ -588,6 +594,141 @@
         <p:cNvPr id="1" name="">
           <a:extLst>
             <a:ext uri="{FF2B5EF4-FFF2-40B4-BE49-F238E27FC236}">
+              <a16:creationId xmlns:a16="http://schemas.microsoft.com/office/drawing/2014/main" id="{98FA8025-7686-BCCC-7DD1-6B328CFA6A82}"/>
+            </a:ext>
+          </a:extLst>
+        </p:cNvPr>
+        <p:cNvGrpSpPr/>
+        <p:nvPr/>
+      </p:nvGrpSpPr>
+      <p:grpSpPr>
+        <a:xfrm>
+          <a:off x="0" y="0"/>
+          <a:ext cx="0" cy="0"/>
+          <a:chOff x="0" y="0"/>
+          <a:chExt cx="0" cy="0"/>
+        </a:xfrm>
+      </p:grpSpPr>
+      <p:sp>
+        <p:nvSpPr>
+          <p:cNvPr id="2" name="Slide Image Placeholder 1">
+            <a:extLst>
+              <a:ext uri="{FF2B5EF4-FFF2-40B4-BE49-F238E27FC236}">
+                <a16:creationId xmlns:a16="http://schemas.microsoft.com/office/drawing/2014/main" id="{CCC966E4-CF19-5930-754F-56603D90B669}"/>
+              </a:ext>
+            </a:extLst>
+          </p:cNvPr>
+          <p:cNvSpPr>
+            <a:spLocks noGrp="1" noRot="1" noChangeAspect="1"/>
+          </p:cNvSpPr>
+          <p:nvPr>
+            <p:ph type="sldImg"/>
+          </p:nvPr>
+        </p:nvSpPr>
+        <p:spPr/>
+      </p:sp>
+      <p:sp>
+        <p:nvSpPr>
+          <p:cNvPr id="3" name="Notes Placeholder 2">
+            <a:extLst>
+              <a:ext uri="{FF2B5EF4-FFF2-40B4-BE49-F238E27FC236}">
+                <a16:creationId xmlns:a16="http://schemas.microsoft.com/office/drawing/2014/main" id="{3D950276-3093-AC60-EE4B-5019DE78249C}"/>
+              </a:ext>
+            </a:extLst>
+          </p:cNvPr>
+          <p:cNvSpPr>
+            <a:spLocks noGrp="1"/>
+          </p:cNvSpPr>
+          <p:nvPr>
+            <p:ph type="body" idx="1"/>
+          </p:nvPr>
+        </p:nvSpPr>
+        <p:spPr/>
+        <p:txBody>
+          <a:bodyPr/>
+          <a:lstStyle/>
+          <a:p>
+            <a:pPr marL="171450" indent="-171450">
+              <a:buFontTx/>
+              <a:buChar char="-"/>
+            </a:pPr>
+            <a:r>
+              <a:rPr lang="en-US" dirty="0"/>
+              <a:t>Time-invariant confounders </a:t>
+            </a:r>
+          </a:p>
+          <a:p>
+            <a:pPr marL="171450" indent="-171450">
+              <a:buFontTx/>
+              <a:buChar char="-"/>
+            </a:pPr>
+            <a:r>
+              <a:rPr lang="en-US" dirty="0"/>
+              <a:t>Methods exist to deal with linear unobserved confounders</a:t>
+            </a:r>
+          </a:p>
+          <a:p>
+            <a:pPr marL="171450" indent="-171450">
+              <a:buFontTx/>
+              <a:buChar char="-"/>
+            </a:pPr>
+            <a:r>
+              <a:rPr lang="en-US" dirty="0"/>
+              <a:t>Methods exist to deal with non-linear confounders if we know their functional form</a:t>
+            </a:r>
+          </a:p>
+        </p:txBody>
+      </p:sp>
+      <p:sp>
+        <p:nvSpPr>
+          <p:cNvPr id="4" name="Slide Number Placeholder 3">
+            <a:extLst>
+              <a:ext uri="{FF2B5EF4-FFF2-40B4-BE49-F238E27FC236}">
+                <a16:creationId xmlns:a16="http://schemas.microsoft.com/office/drawing/2014/main" id="{850F4A7C-658A-3A43-EFD3-4955121A46C3}"/>
+              </a:ext>
+            </a:extLst>
+          </p:cNvPr>
+          <p:cNvSpPr>
+            <a:spLocks noGrp="1"/>
+          </p:cNvSpPr>
+          <p:nvPr>
+            <p:ph type="sldNum" sz="quarter" idx="5"/>
+          </p:nvPr>
+        </p:nvSpPr>
+        <p:spPr/>
+        <p:txBody>
+          <a:bodyPr/>
+          <a:lstStyle/>
+          <a:p>
+            <a:fld id="{0B6BC14E-466D-44BA-BA2E-E5EF27323AAD}" type="slidenum">
+              <a:rPr lang="en-US" smtClean="0"/>
+              <a:t>11</a:t>
+            </a:fld>
+            <a:endParaRPr lang="en-US"/>
+          </a:p>
+        </p:txBody>
+      </p:sp>
+    </p:spTree>
+    <p:extLst>
+      <p:ext uri="{BB962C8B-B14F-4D97-AF65-F5344CB8AC3E}">
+        <p14:creationId xmlns:p14="http://schemas.microsoft.com/office/powerpoint/2010/main" val="3616906700"/>
+      </p:ext>
+    </p:extLst>
+  </p:cSld>
+  <p:clrMapOvr>
+    <a:masterClrMapping/>
+  </p:clrMapOvr>
+</p:notes>
+</file>
+
+<file path=ppt/notesSlides/notesSlide11.xml><?xml version="1.0" encoding="utf-8"?>
+<p:notes xmlns:a="http://schemas.openxmlformats.org/drawingml/2006/main" xmlns:r="http://schemas.openxmlformats.org/officeDocument/2006/relationships" xmlns:p="http://schemas.openxmlformats.org/presentationml/2006/main">
+  <p:cSld>
+    <p:spTree>
+      <p:nvGrpSpPr>
+        <p:cNvPr id="1" name="">
+          <a:extLst>
+            <a:ext uri="{FF2B5EF4-FFF2-40B4-BE49-F238E27FC236}">
               <a16:creationId xmlns:a16="http://schemas.microsoft.com/office/drawing/2014/main" id="{AFE39119-89F2-D27F-7FC8-33979217DE9B}"/>
             </a:ext>
           </a:extLst>
@@ -696,7 +837,7 @@
           <a:p>
             <a:fld id="{0B6BC14E-466D-44BA-BA2E-E5EF27323AAD}" type="slidenum">
               <a:rPr lang="en-US" smtClean="0"/>
-              <a:t>11</a:t>
+              <a:t>12</a:t>
             </a:fld>
             <a:endParaRPr lang="en-US"/>
           </a:p>
@@ -716,141 +857,6 @@
 </file>
 
 <file path=ppt/notesSlides/notesSlide2.xml><?xml version="1.0" encoding="utf-8"?>
-<p:notes xmlns:a="http://schemas.openxmlformats.org/drawingml/2006/main" xmlns:r="http://schemas.openxmlformats.org/officeDocument/2006/relationships" xmlns:p="http://schemas.openxmlformats.org/presentationml/2006/main">
-  <p:cSld>
-    <p:spTree>
-      <p:nvGrpSpPr>
-        <p:cNvPr id="1" name="">
-          <a:extLst>
-            <a:ext uri="{FF2B5EF4-FFF2-40B4-BE49-F238E27FC236}">
-              <a16:creationId xmlns:a16="http://schemas.microsoft.com/office/drawing/2014/main" id="{88AA7FA8-953A-EE68-7F5F-E3CF0A3FE4B7}"/>
-            </a:ext>
-          </a:extLst>
-        </p:cNvPr>
-        <p:cNvGrpSpPr/>
-        <p:nvPr/>
-      </p:nvGrpSpPr>
-      <p:grpSpPr>
-        <a:xfrm>
-          <a:off x="0" y="0"/>
-          <a:ext cx="0" cy="0"/>
-          <a:chOff x="0" y="0"/>
-          <a:chExt cx="0" cy="0"/>
-        </a:xfrm>
-      </p:grpSpPr>
-      <p:sp>
-        <p:nvSpPr>
-          <p:cNvPr id="2" name="Slide Image Placeholder 1">
-            <a:extLst>
-              <a:ext uri="{FF2B5EF4-FFF2-40B4-BE49-F238E27FC236}">
-                <a16:creationId xmlns:a16="http://schemas.microsoft.com/office/drawing/2014/main" id="{E084CDD4-46B4-8494-BFF3-04A6D2ED9008}"/>
-              </a:ext>
-            </a:extLst>
-          </p:cNvPr>
-          <p:cNvSpPr>
-            <a:spLocks noGrp="1" noRot="1" noChangeAspect="1"/>
-          </p:cNvSpPr>
-          <p:nvPr>
-            <p:ph type="sldImg"/>
-          </p:nvPr>
-        </p:nvSpPr>
-        <p:spPr/>
-      </p:sp>
-      <p:sp>
-        <p:nvSpPr>
-          <p:cNvPr id="3" name="Notes Placeholder 2">
-            <a:extLst>
-              <a:ext uri="{FF2B5EF4-FFF2-40B4-BE49-F238E27FC236}">
-                <a16:creationId xmlns:a16="http://schemas.microsoft.com/office/drawing/2014/main" id="{127FDF3E-BAB4-6935-0F4C-52255D3AC6DE}"/>
-              </a:ext>
-            </a:extLst>
-          </p:cNvPr>
-          <p:cNvSpPr>
-            <a:spLocks noGrp="1"/>
-          </p:cNvSpPr>
-          <p:nvPr>
-            <p:ph type="body" idx="1"/>
-          </p:nvPr>
-        </p:nvSpPr>
-        <p:spPr/>
-        <p:txBody>
-          <a:bodyPr/>
-          <a:lstStyle/>
-          <a:p>
-            <a:pPr marL="171450" indent="-171450">
-              <a:buFontTx/>
-              <a:buChar char="-"/>
-            </a:pPr>
-            <a:r>
-              <a:rPr lang="en-US" dirty="0"/>
-              <a:t>Time-invariant confounders </a:t>
-            </a:r>
-          </a:p>
-          <a:p>
-            <a:pPr marL="171450" indent="-171450">
-              <a:buFontTx/>
-              <a:buChar char="-"/>
-            </a:pPr>
-            <a:r>
-              <a:rPr lang="en-US" dirty="0"/>
-              <a:t>Methods exist to deal with linear unobserved confounders</a:t>
-            </a:r>
-          </a:p>
-          <a:p>
-            <a:pPr marL="171450" indent="-171450">
-              <a:buFontTx/>
-              <a:buChar char="-"/>
-            </a:pPr>
-            <a:r>
-              <a:rPr lang="en-US" dirty="0"/>
-              <a:t>Methods exist to deal with non-linear confounders if we know their functional form</a:t>
-            </a:r>
-          </a:p>
-        </p:txBody>
-      </p:sp>
-      <p:sp>
-        <p:nvSpPr>
-          <p:cNvPr id="4" name="Slide Number Placeholder 3">
-            <a:extLst>
-              <a:ext uri="{FF2B5EF4-FFF2-40B4-BE49-F238E27FC236}">
-                <a16:creationId xmlns:a16="http://schemas.microsoft.com/office/drawing/2014/main" id="{46900EB5-FF08-B937-DA6D-EA89DB361D1B}"/>
-              </a:ext>
-            </a:extLst>
-          </p:cNvPr>
-          <p:cNvSpPr>
-            <a:spLocks noGrp="1"/>
-          </p:cNvSpPr>
-          <p:nvPr>
-            <p:ph type="sldNum" sz="quarter" idx="5"/>
-          </p:nvPr>
-        </p:nvSpPr>
-        <p:spPr/>
-        <p:txBody>
-          <a:bodyPr/>
-          <a:lstStyle/>
-          <a:p>
-            <a:fld id="{0B6BC14E-466D-44BA-BA2E-E5EF27323AAD}" type="slidenum">
-              <a:rPr lang="en-US" smtClean="0"/>
-              <a:t>3</a:t>
-            </a:fld>
-            <a:endParaRPr lang="en-US"/>
-          </a:p>
-        </p:txBody>
-      </p:sp>
-    </p:spTree>
-    <p:extLst>
-      <p:ext uri="{BB962C8B-B14F-4D97-AF65-F5344CB8AC3E}">
-        <p14:creationId xmlns:p14="http://schemas.microsoft.com/office/powerpoint/2010/main" val="2068727411"/>
-      </p:ext>
-    </p:extLst>
-  </p:cSld>
-  <p:clrMapOvr>
-    <a:masterClrMapping/>
-  </p:clrMapOvr>
-</p:notes>
-</file>
-
-<file path=ppt/notesSlides/notesSlide3.xml><?xml version="1.0" encoding="utf-8"?>
 <p:notes xmlns:a="http://schemas.openxmlformats.org/drawingml/2006/main" xmlns:r="http://schemas.openxmlformats.org/officeDocument/2006/relationships" xmlns:p="http://schemas.openxmlformats.org/presentationml/2006/main">
   <p:cSld>
     <p:spTree>
@@ -966,7 +972,7 @@
           <a:p>
             <a:fld id="{0B6BC14E-466D-44BA-BA2E-E5EF27323AAD}" type="slidenum">
               <a:rPr lang="en-US" smtClean="0"/>
-              <a:t>4</a:t>
+              <a:t>3</a:t>
             </a:fld>
             <a:endParaRPr lang="en-US"/>
           </a:p>
@@ -985,7 +991,7 @@
 </p:notes>
 </file>
 
-<file path=ppt/notesSlides/notesSlide4.xml><?xml version="1.0" encoding="utf-8"?>
+<file path=ppt/notesSlides/notesSlide3.xml><?xml version="1.0" encoding="utf-8"?>
 <p:notes xmlns:a="http://schemas.openxmlformats.org/drawingml/2006/main" xmlns:r="http://schemas.openxmlformats.org/officeDocument/2006/relationships" xmlns:p="http://schemas.openxmlformats.org/presentationml/2006/main">
   <p:cSld>
     <p:spTree>
@@ -1101,7 +1107,7 @@
           <a:p>
             <a:fld id="{0B6BC14E-466D-44BA-BA2E-E5EF27323AAD}" type="slidenum">
               <a:rPr lang="en-US" smtClean="0"/>
-              <a:t>5</a:t>
+              <a:t>4</a:t>
             </a:fld>
             <a:endParaRPr lang="en-US"/>
           </a:p>
@@ -1111,6 +1117,141 @@
     <p:extLst>
       <p:ext uri="{BB962C8B-B14F-4D97-AF65-F5344CB8AC3E}">
         <p14:creationId xmlns:p14="http://schemas.microsoft.com/office/powerpoint/2010/main" val="2603026057"/>
+      </p:ext>
+    </p:extLst>
+  </p:cSld>
+  <p:clrMapOvr>
+    <a:masterClrMapping/>
+  </p:clrMapOvr>
+</p:notes>
+</file>
+
+<file path=ppt/notesSlides/notesSlide4.xml><?xml version="1.0" encoding="utf-8"?>
+<p:notes xmlns:a="http://schemas.openxmlformats.org/drawingml/2006/main" xmlns:r="http://schemas.openxmlformats.org/officeDocument/2006/relationships" xmlns:p="http://schemas.openxmlformats.org/presentationml/2006/main">
+  <p:cSld>
+    <p:spTree>
+      <p:nvGrpSpPr>
+        <p:cNvPr id="1" name="">
+          <a:extLst>
+            <a:ext uri="{FF2B5EF4-FFF2-40B4-BE49-F238E27FC236}">
+              <a16:creationId xmlns:a16="http://schemas.microsoft.com/office/drawing/2014/main" id="{ACD5FA8D-DFC6-6F6A-29F5-CCB911C4D928}"/>
+            </a:ext>
+          </a:extLst>
+        </p:cNvPr>
+        <p:cNvGrpSpPr/>
+        <p:nvPr/>
+      </p:nvGrpSpPr>
+      <p:grpSpPr>
+        <a:xfrm>
+          <a:off x="0" y="0"/>
+          <a:ext cx="0" cy="0"/>
+          <a:chOff x="0" y="0"/>
+          <a:chExt cx="0" cy="0"/>
+        </a:xfrm>
+      </p:grpSpPr>
+      <p:sp>
+        <p:nvSpPr>
+          <p:cNvPr id="2" name="Slide Image Placeholder 1">
+            <a:extLst>
+              <a:ext uri="{FF2B5EF4-FFF2-40B4-BE49-F238E27FC236}">
+                <a16:creationId xmlns:a16="http://schemas.microsoft.com/office/drawing/2014/main" id="{B6EFBF52-D3C1-5A82-7176-44362210F1D4}"/>
+              </a:ext>
+            </a:extLst>
+          </p:cNvPr>
+          <p:cNvSpPr>
+            <a:spLocks noGrp="1" noRot="1" noChangeAspect="1"/>
+          </p:cNvSpPr>
+          <p:nvPr>
+            <p:ph type="sldImg"/>
+          </p:nvPr>
+        </p:nvSpPr>
+        <p:spPr/>
+      </p:sp>
+      <p:sp>
+        <p:nvSpPr>
+          <p:cNvPr id="3" name="Notes Placeholder 2">
+            <a:extLst>
+              <a:ext uri="{FF2B5EF4-FFF2-40B4-BE49-F238E27FC236}">
+                <a16:creationId xmlns:a16="http://schemas.microsoft.com/office/drawing/2014/main" id="{70CC83E3-6A78-943A-27CC-1E86F0F29176}"/>
+              </a:ext>
+            </a:extLst>
+          </p:cNvPr>
+          <p:cNvSpPr>
+            <a:spLocks noGrp="1"/>
+          </p:cNvSpPr>
+          <p:nvPr>
+            <p:ph type="body" idx="1"/>
+          </p:nvPr>
+        </p:nvSpPr>
+        <p:spPr/>
+        <p:txBody>
+          <a:bodyPr/>
+          <a:lstStyle/>
+          <a:p>
+            <a:pPr marL="171450" indent="-171450">
+              <a:buFontTx/>
+              <a:buChar char="-"/>
+            </a:pPr>
+            <a:r>
+              <a:rPr lang="en-US" dirty="0"/>
+              <a:t>Time-invariant confounders </a:t>
+            </a:r>
+          </a:p>
+          <a:p>
+            <a:pPr marL="171450" indent="-171450">
+              <a:buFontTx/>
+              <a:buChar char="-"/>
+            </a:pPr>
+            <a:r>
+              <a:rPr lang="en-US" dirty="0"/>
+              <a:t>Methods exist to deal with linear unobserved confounders</a:t>
+            </a:r>
+          </a:p>
+          <a:p>
+            <a:pPr marL="171450" indent="-171450">
+              <a:buFontTx/>
+              <a:buChar char="-"/>
+            </a:pPr>
+            <a:r>
+              <a:rPr lang="en-US" dirty="0"/>
+              <a:t>Methods exist to deal with non-linear confounders if we know their functional form</a:t>
+            </a:r>
+          </a:p>
+        </p:txBody>
+      </p:sp>
+      <p:sp>
+        <p:nvSpPr>
+          <p:cNvPr id="4" name="Slide Number Placeholder 3">
+            <a:extLst>
+              <a:ext uri="{FF2B5EF4-FFF2-40B4-BE49-F238E27FC236}">
+                <a16:creationId xmlns:a16="http://schemas.microsoft.com/office/drawing/2014/main" id="{C274A400-A11F-EFA8-298E-A451A40AEB9E}"/>
+              </a:ext>
+            </a:extLst>
+          </p:cNvPr>
+          <p:cNvSpPr>
+            <a:spLocks noGrp="1"/>
+          </p:cNvSpPr>
+          <p:nvPr>
+            <p:ph type="sldNum" sz="quarter" idx="5"/>
+          </p:nvPr>
+        </p:nvSpPr>
+        <p:spPr/>
+        <p:txBody>
+          <a:bodyPr/>
+          <a:lstStyle/>
+          <a:p>
+            <a:fld id="{0B6BC14E-466D-44BA-BA2E-E5EF27323AAD}" type="slidenum">
+              <a:rPr lang="en-US" smtClean="0"/>
+              <a:t>5</a:t>
+            </a:fld>
+            <a:endParaRPr lang="en-US"/>
+          </a:p>
+        </p:txBody>
+      </p:sp>
+    </p:spTree>
+    <p:extLst>
+      <p:ext uri="{BB962C8B-B14F-4D97-AF65-F5344CB8AC3E}">
+        <p14:creationId xmlns:p14="http://schemas.microsoft.com/office/powerpoint/2010/main" val="3876329888"/>
       </p:ext>
     </p:extLst>
   </p:cSld>
@@ -1398,7 +1539,7 @@
         <p:cNvPr id="1" name="">
           <a:extLst>
             <a:ext uri="{FF2B5EF4-FFF2-40B4-BE49-F238E27FC236}">
-              <a16:creationId xmlns:a16="http://schemas.microsoft.com/office/drawing/2014/main" id="{56B0FAB4-7551-3874-E38F-54138109CC9A}"/>
+              <a16:creationId xmlns:a16="http://schemas.microsoft.com/office/drawing/2014/main" id="{21E1B415-ACC8-7D4A-F444-A8C804DA3DEC}"/>
             </a:ext>
           </a:extLst>
         </p:cNvPr>
@@ -1418,7 +1559,7 @@
           <p:cNvPr id="2" name="Slide Image Placeholder 1">
             <a:extLst>
               <a:ext uri="{FF2B5EF4-FFF2-40B4-BE49-F238E27FC236}">
-                <a16:creationId xmlns:a16="http://schemas.microsoft.com/office/drawing/2014/main" id="{5A297E5E-B400-FAA7-F27F-7DDE0AEDF6F9}"/>
+                <a16:creationId xmlns:a16="http://schemas.microsoft.com/office/drawing/2014/main" id="{FDDDC35F-3B7F-B11D-71FE-3573532B71B3}"/>
               </a:ext>
             </a:extLst>
           </p:cNvPr>
@@ -1436,7 +1577,7 @@
           <p:cNvPr id="3" name="Notes Placeholder 2">
             <a:extLst>
               <a:ext uri="{FF2B5EF4-FFF2-40B4-BE49-F238E27FC236}">
-                <a16:creationId xmlns:a16="http://schemas.microsoft.com/office/drawing/2014/main" id="{971707B2-B492-7AFF-A855-291053C2F1D2}"/>
+                <a16:creationId xmlns:a16="http://schemas.microsoft.com/office/drawing/2014/main" id="{87868BBF-D838-68D2-F204-F59285D0441C}"/>
               </a:ext>
             </a:extLst>
           </p:cNvPr>
@@ -1488,7 +1629,7 @@
           <p:cNvPr id="4" name="Slide Number Placeholder 3">
             <a:extLst>
               <a:ext uri="{FF2B5EF4-FFF2-40B4-BE49-F238E27FC236}">
-                <a16:creationId xmlns:a16="http://schemas.microsoft.com/office/drawing/2014/main" id="{8401AE2E-A411-338A-B3C4-6D962B81BD28}"/>
+                <a16:creationId xmlns:a16="http://schemas.microsoft.com/office/drawing/2014/main" id="{C628C408-5AE1-263E-3B1A-C875BB717D03}"/>
               </a:ext>
             </a:extLst>
           </p:cNvPr>
@@ -1515,7 +1656,7 @@
     </p:spTree>
     <p:extLst>
       <p:ext uri="{BB962C8B-B14F-4D97-AF65-F5344CB8AC3E}">
-        <p14:creationId xmlns:p14="http://schemas.microsoft.com/office/powerpoint/2010/main" val="4014990894"/>
+        <p14:creationId xmlns:p14="http://schemas.microsoft.com/office/powerpoint/2010/main" val="554139118"/>
       </p:ext>
     </p:extLst>
   </p:cSld>
@@ -1526,6 +1667,141 @@
 </file>
 
 <file path=ppt/notesSlides/notesSlide8.xml><?xml version="1.0" encoding="utf-8"?>
+<p:notes xmlns:a="http://schemas.openxmlformats.org/drawingml/2006/main" xmlns:r="http://schemas.openxmlformats.org/officeDocument/2006/relationships" xmlns:p="http://schemas.openxmlformats.org/presentationml/2006/main">
+  <p:cSld>
+    <p:spTree>
+      <p:nvGrpSpPr>
+        <p:cNvPr id="1" name="">
+          <a:extLst>
+            <a:ext uri="{FF2B5EF4-FFF2-40B4-BE49-F238E27FC236}">
+              <a16:creationId xmlns:a16="http://schemas.microsoft.com/office/drawing/2014/main" id="{879139D6-54C5-1CC3-5826-C8700235638D}"/>
+            </a:ext>
+          </a:extLst>
+        </p:cNvPr>
+        <p:cNvGrpSpPr/>
+        <p:nvPr/>
+      </p:nvGrpSpPr>
+      <p:grpSpPr>
+        <a:xfrm>
+          <a:off x="0" y="0"/>
+          <a:ext cx="0" cy="0"/>
+          <a:chOff x="0" y="0"/>
+          <a:chExt cx="0" cy="0"/>
+        </a:xfrm>
+      </p:grpSpPr>
+      <p:sp>
+        <p:nvSpPr>
+          <p:cNvPr id="2" name="Slide Image Placeholder 1">
+            <a:extLst>
+              <a:ext uri="{FF2B5EF4-FFF2-40B4-BE49-F238E27FC236}">
+                <a16:creationId xmlns:a16="http://schemas.microsoft.com/office/drawing/2014/main" id="{4D1BDEDB-42BF-FCAE-2CF5-8826B6A04235}"/>
+              </a:ext>
+            </a:extLst>
+          </p:cNvPr>
+          <p:cNvSpPr>
+            <a:spLocks noGrp="1" noRot="1" noChangeAspect="1"/>
+          </p:cNvSpPr>
+          <p:nvPr>
+            <p:ph type="sldImg"/>
+          </p:nvPr>
+        </p:nvSpPr>
+        <p:spPr/>
+      </p:sp>
+      <p:sp>
+        <p:nvSpPr>
+          <p:cNvPr id="3" name="Notes Placeholder 2">
+            <a:extLst>
+              <a:ext uri="{FF2B5EF4-FFF2-40B4-BE49-F238E27FC236}">
+                <a16:creationId xmlns:a16="http://schemas.microsoft.com/office/drawing/2014/main" id="{005ABE35-B307-DDB0-EC9A-C1F0E6A9C294}"/>
+              </a:ext>
+            </a:extLst>
+          </p:cNvPr>
+          <p:cNvSpPr>
+            <a:spLocks noGrp="1"/>
+          </p:cNvSpPr>
+          <p:nvPr>
+            <p:ph type="body" idx="1"/>
+          </p:nvPr>
+        </p:nvSpPr>
+        <p:spPr/>
+        <p:txBody>
+          <a:bodyPr/>
+          <a:lstStyle/>
+          <a:p>
+            <a:pPr marL="171450" indent="-171450">
+              <a:buFontTx/>
+              <a:buChar char="-"/>
+            </a:pPr>
+            <a:r>
+              <a:rPr lang="en-US" dirty="0"/>
+              <a:t>Time-invariant confounders </a:t>
+            </a:r>
+          </a:p>
+          <a:p>
+            <a:pPr marL="171450" indent="-171450">
+              <a:buFontTx/>
+              <a:buChar char="-"/>
+            </a:pPr>
+            <a:r>
+              <a:rPr lang="en-US" dirty="0"/>
+              <a:t>Methods exist to deal with linear unobserved confounders</a:t>
+            </a:r>
+          </a:p>
+          <a:p>
+            <a:pPr marL="171450" indent="-171450">
+              <a:buFontTx/>
+              <a:buChar char="-"/>
+            </a:pPr>
+            <a:r>
+              <a:rPr lang="en-US" dirty="0"/>
+              <a:t>Methods exist to deal with non-linear confounders if we know their functional form</a:t>
+            </a:r>
+          </a:p>
+        </p:txBody>
+      </p:sp>
+      <p:sp>
+        <p:nvSpPr>
+          <p:cNvPr id="4" name="Slide Number Placeholder 3">
+            <a:extLst>
+              <a:ext uri="{FF2B5EF4-FFF2-40B4-BE49-F238E27FC236}">
+                <a16:creationId xmlns:a16="http://schemas.microsoft.com/office/drawing/2014/main" id="{8E96A2C8-61E9-1915-FC18-64D12861E87B}"/>
+              </a:ext>
+            </a:extLst>
+          </p:cNvPr>
+          <p:cNvSpPr>
+            <a:spLocks noGrp="1"/>
+          </p:cNvSpPr>
+          <p:nvPr>
+            <p:ph type="sldNum" sz="quarter" idx="5"/>
+          </p:nvPr>
+        </p:nvSpPr>
+        <p:spPr/>
+        <p:txBody>
+          <a:bodyPr/>
+          <a:lstStyle/>
+          <a:p>
+            <a:fld id="{0B6BC14E-466D-44BA-BA2E-E5EF27323AAD}" type="slidenum">
+              <a:rPr lang="en-US" smtClean="0"/>
+              <a:t>9</a:t>
+            </a:fld>
+            <a:endParaRPr lang="en-US"/>
+          </a:p>
+        </p:txBody>
+      </p:sp>
+    </p:spTree>
+    <p:extLst>
+      <p:ext uri="{BB962C8B-B14F-4D97-AF65-F5344CB8AC3E}">
+        <p14:creationId xmlns:p14="http://schemas.microsoft.com/office/powerpoint/2010/main" val="1721136748"/>
+      </p:ext>
+    </p:extLst>
+  </p:cSld>
+  <p:clrMapOvr>
+    <a:masterClrMapping/>
+  </p:clrMapOvr>
+</p:notes>
+</file>
+
+<file path=ppt/notesSlides/notesSlide9.xml><?xml version="1.0" encoding="utf-8"?>
 <p:notes xmlns:a="http://schemas.openxmlformats.org/drawingml/2006/main" xmlns:r="http://schemas.openxmlformats.org/officeDocument/2006/relationships" xmlns:p="http://schemas.openxmlformats.org/presentationml/2006/main">
   <p:cSld>
     <p:spTree>
@@ -1641,7 +1917,7 @@
           <a:p>
             <a:fld id="{0B6BC14E-466D-44BA-BA2E-E5EF27323AAD}" type="slidenum">
               <a:rPr lang="en-US" smtClean="0"/>
-              <a:t>9</a:t>
+              <a:t>10</a:t>
             </a:fld>
             <a:endParaRPr lang="en-US"/>
           </a:p>
@@ -1651,141 +1927,6 @@
     <p:extLst>
       <p:ext uri="{BB962C8B-B14F-4D97-AF65-F5344CB8AC3E}">
         <p14:creationId xmlns:p14="http://schemas.microsoft.com/office/powerpoint/2010/main" val="2204954712"/>
-      </p:ext>
-    </p:extLst>
-  </p:cSld>
-  <p:clrMapOvr>
-    <a:masterClrMapping/>
-  </p:clrMapOvr>
-</p:notes>
-</file>
-
-<file path=ppt/notesSlides/notesSlide9.xml><?xml version="1.0" encoding="utf-8"?>
-<p:notes xmlns:a="http://schemas.openxmlformats.org/drawingml/2006/main" xmlns:r="http://schemas.openxmlformats.org/officeDocument/2006/relationships" xmlns:p="http://schemas.openxmlformats.org/presentationml/2006/main">
-  <p:cSld>
-    <p:spTree>
-      <p:nvGrpSpPr>
-        <p:cNvPr id="1" name="">
-          <a:extLst>
-            <a:ext uri="{FF2B5EF4-FFF2-40B4-BE49-F238E27FC236}">
-              <a16:creationId xmlns:a16="http://schemas.microsoft.com/office/drawing/2014/main" id="{98FA8025-7686-BCCC-7DD1-6B328CFA6A82}"/>
-            </a:ext>
-          </a:extLst>
-        </p:cNvPr>
-        <p:cNvGrpSpPr/>
-        <p:nvPr/>
-      </p:nvGrpSpPr>
-      <p:grpSpPr>
-        <a:xfrm>
-          <a:off x="0" y="0"/>
-          <a:ext cx="0" cy="0"/>
-          <a:chOff x="0" y="0"/>
-          <a:chExt cx="0" cy="0"/>
-        </a:xfrm>
-      </p:grpSpPr>
-      <p:sp>
-        <p:nvSpPr>
-          <p:cNvPr id="2" name="Slide Image Placeholder 1">
-            <a:extLst>
-              <a:ext uri="{FF2B5EF4-FFF2-40B4-BE49-F238E27FC236}">
-                <a16:creationId xmlns:a16="http://schemas.microsoft.com/office/drawing/2014/main" id="{CCC966E4-CF19-5930-754F-56603D90B669}"/>
-              </a:ext>
-            </a:extLst>
-          </p:cNvPr>
-          <p:cNvSpPr>
-            <a:spLocks noGrp="1" noRot="1" noChangeAspect="1"/>
-          </p:cNvSpPr>
-          <p:nvPr>
-            <p:ph type="sldImg"/>
-          </p:nvPr>
-        </p:nvSpPr>
-        <p:spPr/>
-      </p:sp>
-      <p:sp>
-        <p:nvSpPr>
-          <p:cNvPr id="3" name="Notes Placeholder 2">
-            <a:extLst>
-              <a:ext uri="{FF2B5EF4-FFF2-40B4-BE49-F238E27FC236}">
-                <a16:creationId xmlns:a16="http://schemas.microsoft.com/office/drawing/2014/main" id="{3D950276-3093-AC60-EE4B-5019DE78249C}"/>
-              </a:ext>
-            </a:extLst>
-          </p:cNvPr>
-          <p:cNvSpPr>
-            <a:spLocks noGrp="1"/>
-          </p:cNvSpPr>
-          <p:nvPr>
-            <p:ph type="body" idx="1"/>
-          </p:nvPr>
-        </p:nvSpPr>
-        <p:spPr/>
-        <p:txBody>
-          <a:bodyPr/>
-          <a:lstStyle/>
-          <a:p>
-            <a:pPr marL="171450" indent="-171450">
-              <a:buFontTx/>
-              <a:buChar char="-"/>
-            </a:pPr>
-            <a:r>
-              <a:rPr lang="en-US" dirty="0"/>
-              <a:t>Time-invariant confounders </a:t>
-            </a:r>
-          </a:p>
-          <a:p>
-            <a:pPr marL="171450" indent="-171450">
-              <a:buFontTx/>
-              <a:buChar char="-"/>
-            </a:pPr>
-            <a:r>
-              <a:rPr lang="en-US" dirty="0"/>
-              <a:t>Methods exist to deal with linear unobserved confounders</a:t>
-            </a:r>
-          </a:p>
-          <a:p>
-            <a:pPr marL="171450" indent="-171450">
-              <a:buFontTx/>
-              <a:buChar char="-"/>
-            </a:pPr>
-            <a:r>
-              <a:rPr lang="en-US" dirty="0"/>
-              <a:t>Methods exist to deal with non-linear confounders if we know their functional form</a:t>
-            </a:r>
-          </a:p>
-        </p:txBody>
-      </p:sp>
-      <p:sp>
-        <p:nvSpPr>
-          <p:cNvPr id="4" name="Slide Number Placeholder 3">
-            <a:extLst>
-              <a:ext uri="{FF2B5EF4-FFF2-40B4-BE49-F238E27FC236}">
-                <a16:creationId xmlns:a16="http://schemas.microsoft.com/office/drawing/2014/main" id="{850F4A7C-658A-3A43-EFD3-4955121A46C3}"/>
-              </a:ext>
-            </a:extLst>
-          </p:cNvPr>
-          <p:cNvSpPr>
-            <a:spLocks noGrp="1"/>
-          </p:cNvSpPr>
-          <p:nvPr>
-            <p:ph type="sldNum" sz="quarter" idx="5"/>
-          </p:nvPr>
-        </p:nvSpPr>
-        <p:spPr/>
-        <p:txBody>
-          <a:bodyPr/>
-          <a:lstStyle/>
-          <a:p>
-            <a:fld id="{0B6BC14E-466D-44BA-BA2E-E5EF27323AAD}" type="slidenum">
-              <a:rPr lang="en-US" smtClean="0"/>
-              <a:t>10</a:t>
-            </a:fld>
-            <a:endParaRPr lang="en-US"/>
-          </a:p>
-        </p:txBody>
-      </p:sp>
-    </p:spTree>
-    <p:extLst>
-      <p:ext uri="{BB962C8B-B14F-4D97-AF65-F5344CB8AC3E}">
-        <p14:creationId xmlns:p14="http://schemas.microsoft.com/office/powerpoint/2010/main" val="3616906700"/>
       </p:ext>
     </p:extLst>
   </p:cSld>
@@ -1942,7 +2083,7 @@
           <a:p>
             <a:fld id="{3ADAA44F-27F9-41EB-9599-B394A88B5CFE}" type="datetimeFigureOut">
               <a:rPr lang="en-US" smtClean="0"/>
-              <a:t>11/18/2025</a:t>
+              <a:t>11/25/2025</a:t>
             </a:fld>
             <a:endParaRPr lang="en-US"/>
           </a:p>
@@ -2140,7 +2281,7 @@
           <a:p>
             <a:fld id="{3ADAA44F-27F9-41EB-9599-B394A88B5CFE}" type="datetimeFigureOut">
               <a:rPr lang="en-US" smtClean="0"/>
-              <a:t>11/18/2025</a:t>
+              <a:t>11/25/2025</a:t>
             </a:fld>
             <a:endParaRPr lang="en-US"/>
           </a:p>
@@ -2348,7 +2489,7 @@
           <a:p>
             <a:fld id="{3ADAA44F-27F9-41EB-9599-B394A88B5CFE}" type="datetimeFigureOut">
               <a:rPr lang="en-US" smtClean="0"/>
-              <a:t>11/18/2025</a:t>
+              <a:t>11/25/2025</a:t>
             </a:fld>
             <a:endParaRPr lang="en-US"/>
           </a:p>
@@ -2546,7 +2687,7 @@
           <a:p>
             <a:fld id="{3ADAA44F-27F9-41EB-9599-B394A88B5CFE}" type="datetimeFigureOut">
               <a:rPr lang="en-US" smtClean="0"/>
-              <a:t>11/18/2025</a:t>
+              <a:t>11/25/2025</a:t>
             </a:fld>
             <a:endParaRPr lang="en-US"/>
           </a:p>
@@ -2821,7 +2962,7 @@
           <a:p>
             <a:fld id="{3ADAA44F-27F9-41EB-9599-B394A88B5CFE}" type="datetimeFigureOut">
               <a:rPr lang="en-US" smtClean="0"/>
-              <a:t>11/18/2025</a:t>
+              <a:t>11/25/2025</a:t>
             </a:fld>
             <a:endParaRPr lang="en-US"/>
           </a:p>
@@ -3086,7 +3227,7 @@
           <a:p>
             <a:fld id="{3ADAA44F-27F9-41EB-9599-B394A88B5CFE}" type="datetimeFigureOut">
               <a:rPr lang="en-US" smtClean="0"/>
-              <a:t>11/18/2025</a:t>
+              <a:t>11/25/2025</a:t>
             </a:fld>
             <a:endParaRPr lang="en-US"/>
           </a:p>
@@ -3498,7 +3639,7 @@
           <a:p>
             <a:fld id="{3ADAA44F-27F9-41EB-9599-B394A88B5CFE}" type="datetimeFigureOut">
               <a:rPr lang="en-US" smtClean="0"/>
-              <a:t>11/18/2025</a:t>
+              <a:t>11/25/2025</a:t>
             </a:fld>
             <a:endParaRPr lang="en-US"/>
           </a:p>
@@ -3639,7 +3780,7 @@
           <a:p>
             <a:fld id="{3ADAA44F-27F9-41EB-9599-B394A88B5CFE}" type="datetimeFigureOut">
               <a:rPr lang="en-US" smtClean="0"/>
-              <a:t>11/18/2025</a:t>
+              <a:t>11/25/2025</a:t>
             </a:fld>
             <a:endParaRPr lang="en-US"/>
           </a:p>
@@ -3752,7 +3893,7 @@
           <a:p>
             <a:fld id="{3ADAA44F-27F9-41EB-9599-B394A88B5CFE}" type="datetimeFigureOut">
               <a:rPr lang="en-US" smtClean="0"/>
-              <a:t>11/18/2025</a:t>
+              <a:t>11/25/2025</a:t>
             </a:fld>
             <a:endParaRPr lang="en-US"/>
           </a:p>
@@ -4063,7 +4204,7 @@
           <a:p>
             <a:fld id="{3ADAA44F-27F9-41EB-9599-B394A88B5CFE}" type="datetimeFigureOut">
               <a:rPr lang="en-US" smtClean="0"/>
-              <a:t>11/18/2025</a:t>
+              <a:t>11/25/2025</a:t>
             </a:fld>
             <a:endParaRPr lang="en-US"/>
           </a:p>
@@ -4351,7 +4492,7 @@
           <a:p>
             <a:fld id="{3ADAA44F-27F9-41EB-9599-B394A88B5CFE}" type="datetimeFigureOut">
               <a:rPr lang="en-US" smtClean="0"/>
-              <a:t>11/18/2025</a:t>
+              <a:t>11/25/2025</a:t>
             </a:fld>
             <a:endParaRPr lang="en-US"/>
           </a:p>
@@ -4592,7 +4733,7 @@
           <a:p>
             <a:fld id="{3ADAA44F-27F9-41EB-9599-B394A88B5CFE}" type="datetimeFigureOut">
               <a:rPr lang="en-US" smtClean="0"/>
-              <a:t>11/18/2025</a:t>
+              <a:t>11/25/2025</a:t>
             </a:fld>
             <a:endParaRPr lang="en-US"/>
           </a:p>
@@ -5643,7 +5784,7 @@
         <p:cNvPr id="1" name="">
           <a:extLst>
             <a:ext uri="{FF2B5EF4-FFF2-40B4-BE49-F238E27FC236}">
-              <a16:creationId xmlns:a16="http://schemas.microsoft.com/office/drawing/2014/main" id="{4DC7E385-3056-2E89-E5BF-5C042D37CD3C}"/>
+              <a16:creationId xmlns:a16="http://schemas.microsoft.com/office/drawing/2014/main" id="{4E70D5D5-9C56-230B-329D-DFD5F55681F3}"/>
             </a:ext>
           </a:extLst>
         </p:cNvPr>
@@ -5660,10 +5801,10 @@
       </p:grpSpPr>
       <p:sp>
         <p:nvSpPr>
-          <p:cNvPr id="12" name="Rectangle 11">
-            <a:extLst>
-              <a:ext uri="{FF2B5EF4-FFF2-40B4-BE49-F238E27FC236}">
-                <a16:creationId xmlns:a16="http://schemas.microsoft.com/office/drawing/2014/main" id="{6753252F-4873-4F63-801D-CC719279A7D5}"/>
+          <p:cNvPr id="10" name="Rectangle 9">
+            <a:extLst>
+              <a:ext uri="{FF2B5EF4-FFF2-40B4-BE49-F238E27FC236}">
+                <a16:creationId xmlns:a16="http://schemas.microsoft.com/office/drawing/2014/main" id="{27AB6FD3-FA5D-38FB-B381-28A41D080A17}"/>
               </a:ext>
               <a:ext uri="{C183D7F6-B498-43B3-948B-1728B52AA6E4}">
                 <adec:decorative xmlns:adec="http://schemas.microsoft.com/office/drawing/2017/decorative" val="1"/>
@@ -5723,6 +5864,265 @@
       </p:sp>
       <p:sp>
         <p:nvSpPr>
+          <p:cNvPr id="12" name="Rectangle 11">
+            <a:extLst>
+              <a:ext uri="{FF2B5EF4-FFF2-40B4-BE49-F238E27FC236}">
+                <a16:creationId xmlns:a16="http://schemas.microsoft.com/office/drawing/2014/main" id="{D12682AF-82BF-2486-D716-B7A49E86ED75}"/>
+              </a:ext>
+              <a:ext uri="{C183D7F6-B498-43B3-948B-1728B52AA6E4}">
+                <adec:decorative xmlns:adec="http://schemas.microsoft.com/office/drawing/2017/decorative" val="1"/>
+              </a:ext>
+            </a:extLst>
+          </p:cNvPr>
+          <p:cNvSpPr>
+            <a:spLocks noGrp="1" noRot="1" noChangeAspect="1" noMove="1" noResize="1" noEditPoints="1" noAdjustHandles="1" noChangeArrowheads="1" noChangeShapeType="1" noTextEdit="1"/>
+          </p:cNvSpPr>
+          <p:nvPr>
+            <p:extLst>
+              <p:ext uri="{386F3935-93C4-4BCD-93E2-E3B085C9AB24}">
+                <p16:designElem xmlns:p16="http://schemas.microsoft.com/office/powerpoint/2015/main" val="1"/>
+              </p:ext>
+            </p:extLst>
+          </p:nvPr>
+        </p:nvSpPr>
+        <p:spPr>
+          <a:xfrm>
+            <a:off x="0" y="0"/>
+            <a:ext cx="2013557" cy="6858000"/>
+          </a:xfrm>
+          <a:prstGeom prst="rect">
+            <a:avLst/>
+          </a:prstGeom>
+          <a:solidFill>
+            <a:srgbClr val="383B64"/>
+          </a:solidFill>
+          <a:ln>
+            <a:noFill/>
+          </a:ln>
+        </p:spPr>
+        <p:style>
+          <a:lnRef idx="2">
+            <a:schemeClr val="accent1">
+              <a:shade val="50000"/>
+            </a:schemeClr>
+          </a:lnRef>
+          <a:fillRef idx="1">
+            <a:schemeClr val="accent1"/>
+          </a:fillRef>
+          <a:effectRef idx="0">
+            <a:schemeClr val="accent1"/>
+          </a:effectRef>
+          <a:fontRef idx="minor">
+            <a:schemeClr val="lt1"/>
+          </a:fontRef>
+        </p:style>
+        <p:txBody>
+          <a:bodyPr rtlCol="0" anchor="ctr"/>
+          <a:lstStyle/>
+          <a:p>
+            <a:pPr algn="ctr"/>
+            <a:endParaRPr lang="en-US"/>
+          </a:p>
+        </p:txBody>
+      </p:sp>
+      <p:sp>
+        <p:nvSpPr>
+          <p:cNvPr id="2" name="Title 1">
+            <a:extLst>
+              <a:ext uri="{FF2B5EF4-FFF2-40B4-BE49-F238E27FC236}">
+                <a16:creationId xmlns:a16="http://schemas.microsoft.com/office/drawing/2014/main" id="{5E3070DB-C71B-F001-EF5B-8357FEC216D6}"/>
+              </a:ext>
+            </a:extLst>
+          </p:cNvPr>
+          <p:cNvSpPr>
+            <a:spLocks noGrp="1"/>
+          </p:cNvSpPr>
+          <p:nvPr>
+            <p:ph type="title"/>
+          </p:nvPr>
+        </p:nvSpPr>
+        <p:spPr>
+          <a:xfrm>
+            <a:off x="640080" y="2074363"/>
+            <a:ext cx="2752354" cy="2709275"/>
+          </a:xfrm>
+          <a:prstGeom prst="ellipse">
+            <a:avLst/>
+          </a:prstGeom>
+          <a:solidFill>
+            <a:srgbClr val="262626"/>
+          </a:solidFill>
+          <a:ln w="174625" cmpd="thinThick">
+            <a:solidFill>
+              <a:srgbClr val="262626"/>
+            </a:solidFill>
+          </a:ln>
+        </p:spPr>
+        <p:txBody>
+          <a:bodyPr vert="horz" lIns="91440" tIns="45720" rIns="91440" bIns="45720" rtlCol="0" anchor="ctr">
+            <a:normAutofit/>
+          </a:bodyPr>
+          <a:lstStyle/>
+          <a:p>
+            <a:pPr algn="ctr"/>
+            <a:r>
+              <a:rPr lang="en-US" sz="2600" dirty="0">
+                <a:solidFill>
+                  <a:srgbClr val="FFFFFF"/>
+                </a:solidFill>
+              </a:rPr>
+              <a:t>Models</a:t>
+            </a:r>
+            <a:endParaRPr lang="en-US" sz="2600" kern="1200" dirty="0">
+              <a:solidFill>
+                <a:srgbClr val="FFFFFF"/>
+              </a:solidFill>
+              <a:latin typeface="+mj-lt"/>
+              <a:ea typeface="+mj-ea"/>
+              <a:cs typeface="+mj-cs"/>
+            </a:endParaRPr>
+          </a:p>
+        </p:txBody>
+      </p:sp>
+      <p:pic>
+        <p:nvPicPr>
+          <p:cNvPr id="4" name="Picture 3">
+            <a:extLst>
+              <a:ext uri="{FF2B5EF4-FFF2-40B4-BE49-F238E27FC236}">
+                <a16:creationId xmlns:a16="http://schemas.microsoft.com/office/drawing/2014/main" id="{471752A8-4050-B385-60BB-186B159A3A79}"/>
+              </a:ext>
+            </a:extLst>
+          </p:cNvPr>
+          <p:cNvPicPr>
+            <a:picLocks noChangeAspect="1"/>
+          </p:cNvPicPr>
+          <p:nvPr/>
+        </p:nvPicPr>
+        <p:blipFill>
+          <a:blip r:embed="rId3"/>
+          <a:stretch>
+            <a:fillRect/>
+          </a:stretch>
+        </p:blipFill>
+        <p:spPr>
+          <a:xfrm>
+            <a:off x="4536191" y="1864307"/>
+            <a:ext cx="5619750" cy="3476625"/>
+          </a:xfrm>
+          <a:prstGeom prst="rect">
+            <a:avLst/>
+          </a:prstGeom>
+        </p:spPr>
+      </p:pic>
+    </p:spTree>
+    <p:extLst>
+      <p:ext uri="{BB962C8B-B14F-4D97-AF65-F5344CB8AC3E}">
+        <p14:creationId xmlns:p14="http://schemas.microsoft.com/office/powerpoint/2010/main" val="1163571441"/>
+      </p:ext>
+    </p:extLst>
+  </p:cSld>
+  <p:clrMapOvr>
+    <a:masterClrMapping/>
+  </p:clrMapOvr>
+</p:sld>
+</file>
+
+<file path=ppt/slides/slide11.xml><?xml version="1.0" encoding="utf-8"?>
+<p:sld xmlns:a="http://schemas.openxmlformats.org/drawingml/2006/main" xmlns:r="http://schemas.openxmlformats.org/officeDocument/2006/relationships" xmlns:p="http://schemas.openxmlformats.org/presentationml/2006/main">
+  <p:cSld>
+    <p:bg>
+      <p:bgPr>
+        <a:solidFill>
+          <a:schemeClr val="bg1"/>
+        </a:solidFill>
+        <a:effectLst/>
+      </p:bgPr>
+    </p:bg>
+    <p:spTree>
+      <p:nvGrpSpPr>
+        <p:cNvPr id="1" name="">
+          <a:extLst>
+            <a:ext uri="{FF2B5EF4-FFF2-40B4-BE49-F238E27FC236}">
+              <a16:creationId xmlns:a16="http://schemas.microsoft.com/office/drawing/2014/main" id="{4DC7E385-3056-2E89-E5BF-5C042D37CD3C}"/>
+            </a:ext>
+          </a:extLst>
+        </p:cNvPr>
+        <p:cNvGrpSpPr/>
+        <p:nvPr/>
+      </p:nvGrpSpPr>
+      <p:grpSpPr>
+        <a:xfrm>
+          <a:off x="0" y="0"/>
+          <a:ext cx="0" cy="0"/>
+          <a:chOff x="0" y="0"/>
+          <a:chExt cx="0" cy="0"/>
+        </a:xfrm>
+      </p:grpSpPr>
+      <p:sp>
+        <p:nvSpPr>
+          <p:cNvPr id="12" name="Rectangle 11">
+            <a:extLst>
+              <a:ext uri="{FF2B5EF4-FFF2-40B4-BE49-F238E27FC236}">
+                <a16:creationId xmlns:a16="http://schemas.microsoft.com/office/drawing/2014/main" id="{6753252F-4873-4F63-801D-CC719279A7D5}"/>
+              </a:ext>
+              <a:ext uri="{C183D7F6-B498-43B3-948B-1728B52AA6E4}">
+                <adec:decorative xmlns:adec="http://schemas.microsoft.com/office/drawing/2017/decorative" val="1"/>
+              </a:ext>
+            </a:extLst>
+          </p:cNvPr>
+          <p:cNvSpPr>
+            <a:spLocks noGrp="1" noRot="1" noChangeAspect="1" noMove="1" noResize="1" noEditPoints="1" noAdjustHandles="1" noChangeArrowheads="1" noChangeShapeType="1" noTextEdit="1"/>
+          </p:cNvSpPr>
+          <p:nvPr>
+            <p:extLst>
+              <p:ext uri="{386F3935-93C4-4BCD-93E2-E3B085C9AB24}">
+                <p16:designElem xmlns:p16="http://schemas.microsoft.com/office/powerpoint/2015/main" val="1"/>
+              </p:ext>
+            </p:extLst>
+          </p:nvPr>
+        </p:nvSpPr>
+        <p:spPr>
+          <a:xfrm>
+            <a:off x="0" y="0"/>
+            <a:ext cx="12192000" cy="6858000"/>
+          </a:xfrm>
+          <a:prstGeom prst="rect">
+            <a:avLst/>
+          </a:prstGeom>
+          <a:solidFill>
+            <a:srgbClr val="FFFFFF"/>
+          </a:solidFill>
+          <a:ln>
+            <a:noFill/>
+          </a:ln>
+        </p:spPr>
+        <p:style>
+          <a:lnRef idx="2">
+            <a:schemeClr val="accent1">
+              <a:shade val="50000"/>
+            </a:schemeClr>
+          </a:lnRef>
+          <a:fillRef idx="1">
+            <a:schemeClr val="accent1"/>
+          </a:fillRef>
+          <a:effectRef idx="0">
+            <a:schemeClr val="accent1"/>
+          </a:effectRef>
+          <a:fontRef idx="minor">
+            <a:schemeClr val="lt1"/>
+          </a:fontRef>
+        </p:style>
+        <p:txBody>
+          <a:bodyPr rtlCol="0" anchor="ctr"/>
+          <a:lstStyle/>
+          <a:p>
+            <a:pPr algn="ctr"/>
+            <a:endParaRPr lang="en-US"/>
+          </a:p>
+        </p:txBody>
+      </p:sp>
+      <p:sp>
+        <p:nvSpPr>
           <p:cNvPr id="14" name="Rectangle 13">
             <a:extLst>
               <a:ext uri="{FF2B5EF4-FFF2-40B4-BE49-F238E27FC236}">
@@ -5889,7 +6289,7 @@
 </p:sld>
 </file>
 
-<file path=ppt/slides/slide11.xml><?xml version="1.0" encoding="utf-8"?>
+<file path=ppt/slides/slide12.xml><?xml version="1.0" encoding="utf-8"?>
 <p:sld xmlns:a="http://schemas.openxmlformats.org/drawingml/2006/main" xmlns:r="http://schemas.openxmlformats.org/officeDocument/2006/relationships" xmlns:p="http://schemas.openxmlformats.org/presentationml/2006/main">
   <p:cSld>
     <p:bg>
@@ -6786,7 +7186,7 @@
         <p:cNvPr id="1" name="">
           <a:extLst>
             <a:ext uri="{FF2B5EF4-FFF2-40B4-BE49-F238E27FC236}">
-              <a16:creationId xmlns:a16="http://schemas.microsoft.com/office/drawing/2014/main" id="{C98CFB4D-D8AA-2530-9DEC-C1063CA4D34F}"/>
+              <a16:creationId xmlns:a16="http://schemas.microsoft.com/office/drawing/2014/main" id="{666EF35C-F0C0-1E9A-3BDA-A81F427161CF}"/>
             </a:ext>
           </a:extLst>
         </p:cNvPr>
@@ -6806,7 +7206,7 @@
           <p:cNvPr id="10" name="Rectangle 9">
             <a:extLst>
               <a:ext uri="{FF2B5EF4-FFF2-40B4-BE49-F238E27FC236}">
-                <a16:creationId xmlns:a16="http://schemas.microsoft.com/office/drawing/2014/main" id="{6753252F-4873-4F63-801D-CC719279A7D5}"/>
+                <a16:creationId xmlns:a16="http://schemas.microsoft.com/office/drawing/2014/main" id="{47701928-3275-56E6-5F0E-C682893C9F98}"/>
               </a:ext>
               <a:ext uri="{C183D7F6-B498-43B3-948B-1728B52AA6E4}">
                 <adec:decorative xmlns:adec="http://schemas.microsoft.com/office/drawing/2017/decorative" val="1"/>
@@ -6869,7 +7269,7 @@
           <p:cNvPr id="12" name="Rectangle 11">
             <a:extLst>
               <a:ext uri="{FF2B5EF4-FFF2-40B4-BE49-F238E27FC236}">
-                <a16:creationId xmlns:a16="http://schemas.microsoft.com/office/drawing/2014/main" id="{047C8CCB-F95D-4249-92DD-651249D3535A}"/>
+                <a16:creationId xmlns:a16="http://schemas.microsoft.com/office/drawing/2014/main" id="{2FAEF9D4-216C-3035-594D-80BE1E08CBF4}"/>
               </a:ext>
               <a:ext uri="{C183D7F6-B498-43B3-948B-1728B52AA6E4}">
                 <adec:decorative xmlns:adec="http://schemas.microsoft.com/office/drawing/2017/decorative" val="1"/>
@@ -6932,7 +7332,7 @@
           <p:cNvPr id="2" name="Title 1">
             <a:extLst>
               <a:ext uri="{FF2B5EF4-FFF2-40B4-BE49-F238E27FC236}">
-                <a16:creationId xmlns:a16="http://schemas.microsoft.com/office/drawing/2014/main" id="{76FD3BC1-38DB-9557-3A6D-5976DD64EB08}"/>
+                <a16:creationId xmlns:a16="http://schemas.microsoft.com/office/drawing/2014/main" id="{EDCBE170-BE89-06EC-80D8-F8866FB3FBF6}"/>
               </a:ext>
             </a:extLst>
           </p:cNvPr>
@@ -6968,7 +7368,7 @@
           <a:p>
             <a:pPr algn="ctr"/>
             <a:r>
-              <a:rPr lang="en-US" sz="2600" kern="1200">
+              <a:rPr lang="en-US" sz="2600" kern="1200" dirty="0">
                 <a:solidFill>
                   <a:srgbClr val="FFFFFF"/>
                 </a:solidFill>
@@ -6976,53 +7376,84 @@
                 <a:ea typeface="+mj-ea"/>
                 <a:cs typeface="+mj-cs"/>
               </a:rPr>
-              <a:t>Problem / RQ</a:t>
-            </a:r>
-          </a:p>
-        </p:txBody>
-      </p:sp>
-      <p:pic>
-        <p:nvPicPr>
-          <p:cNvPr id="5" name="Content Placeholder 4" descr="A graph of a graph of a graph&#10;&#10;AI-generated content may be incorrect.">
-            <a:extLst>
-              <a:ext uri="{FF2B5EF4-FFF2-40B4-BE49-F238E27FC236}">
-                <a16:creationId xmlns:a16="http://schemas.microsoft.com/office/drawing/2014/main" id="{AFB09C59-2E7B-CF1A-F65E-708870245619}"/>
-              </a:ext>
-            </a:extLst>
-          </p:cNvPr>
-          <p:cNvPicPr>
-            <a:picLocks noGrp="1" noChangeAspect="1"/>
-          </p:cNvPicPr>
-          <p:nvPr>
-            <p:ph idx="1"/>
-          </p:nvPr>
-        </p:nvPicPr>
-        <p:blipFill>
-          <a:blip r:embed="rId3">
-            <a:extLst>
-              <a:ext uri="{28A0092B-C50C-407E-A947-70E740481C1C}">
-                <a14:useLocalDpi xmlns:a14="http://schemas.microsoft.com/office/drawing/2010/main" val="0"/>
-              </a:ext>
-            </a:extLst>
-          </a:blip>
-          <a:stretch>
-            <a:fillRect/>
-          </a:stretch>
-        </p:blipFill>
+              <a:t>BCA SEM</a:t>
+            </a:r>
+          </a:p>
+        </p:txBody>
+      </p:sp>
+      <p:sp>
+        <p:nvSpPr>
+          <p:cNvPr id="14" name="TextBox 13">
+            <a:extLst>
+              <a:ext uri="{FF2B5EF4-FFF2-40B4-BE49-F238E27FC236}">
+                <a16:creationId xmlns:a16="http://schemas.microsoft.com/office/drawing/2014/main" id="{AA18D2CF-5741-17E2-9D54-58A4BE4064A8}"/>
+              </a:ext>
+            </a:extLst>
+          </p:cNvPr>
+          <p:cNvSpPr txBox="1"/>
+          <p:nvPr/>
+        </p:nvSpPr>
         <p:spPr>
           <a:xfrm>
-            <a:off x="4085227" y="961812"/>
-            <a:ext cx="7094944" cy="4930987"/>
+            <a:off x="4132161" y="2627453"/>
+            <a:ext cx="6875362" cy="1200329"/>
           </a:xfrm>
           <a:prstGeom prst="rect">
             <a:avLst/>
           </a:prstGeom>
+          <a:noFill/>
         </p:spPr>
-      </p:pic>
+        <p:txBody>
+          <a:bodyPr wrap="square" rtlCol="0">
+            <a:spAutoFit/>
+          </a:bodyPr>
+          <a:lstStyle/>
+          <a:p>
+            <a:r>
+              <a:rPr lang="en-US" dirty="0"/>
+              <a:t>Step 1: Regress </a:t>
+            </a:r>
+            <a:r>
+              <a:rPr lang="en-US" dirty="0" err="1"/>
+              <a:t>X_t</a:t>
+            </a:r>
+            <a:r>
+              <a:rPr lang="en-US" dirty="0"/>
+              <a:t> (and </a:t>
+            </a:r>
+            <a:r>
+              <a:rPr lang="en-US" dirty="0" err="1"/>
+              <a:t>Y_t</a:t>
+            </a:r>
+            <a:r>
+              <a:rPr lang="en-US" dirty="0"/>
+              <a:t>) on C</a:t>
+            </a:r>
+          </a:p>
+          <a:p>
+            <a:r>
+              <a:rPr lang="en-US" dirty="0"/>
+              <a:t>Step 2: Save the residuals</a:t>
+            </a:r>
+          </a:p>
+          <a:p>
+            <a:r>
+              <a:rPr lang="en-US" dirty="0"/>
+              <a:t>Step 3: Do your standard CLPM</a:t>
+            </a:r>
+          </a:p>
+          <a:p>
+            <a:r>
+              <a:rPr lang="en-US" dirty="0"/>
+              <a:t>Step 4: Oops we should have bootstrapped to estimate our errors. </a:t>
+            </a:r>
+          </a:p>
+        </p:txBody>
+      </p:sp>
     </p:spTree>
     <p:extLst>
       <p:ext uri="{BB962C8B-B14F-4D97-AF65-F5344CB8AC3E}">
-        <p14:creationId xmlns:p14="http://schemas.microsoft.com/office/powerpoint/2010/main" val="1993057980"/>
+        <p14:creationId xmlns:p14="http://schemas.microsoft.com/office/powerpoint/2010/main" val="3220156857"/>
       </p:ext>
     </p:extLst>
   </p:cSld>
@@ -7048,7 +7479,7 @@
         <p:cNvPr id="1" name="">
           <a:extLst>
             <a:ext uri="{FF2B5EF4-FFF2-40B4-BE49-F238E27FC236}">
-              <a16:creationId xmlns:a16="http://schemas.microsoft.com/office/drawing/2014/main" id="{666EF35C-F0C0-1E9A-3BDA-A81F427161CF}"/>
+              <a16:creationId xmlns:a16="http://schemas.microsoft.com/office/drawing/2014/main" id="{F9C7C219-9DB4-DAD3-B98D-ED0FBBBC25C4}"/>
             </a:ext>
           </a:extLst>
         </p:cNvPr>
@@ -7068,7 +7499,7 @@
           <p:cNvPr id="10" name="Rectangle 9">
             <a:extLst>
               <a:ext uri="{FF2B5EF4-FFF2-40B4-BE49-F238E27FC236}">
-                <a16:creationId xmlns:a16="http://schemas.microsoft.com/office/drawing/2014/main" id="{47701928-3275-56E6-5F0E-C682893C9F98}"/>
+                <a16:creationId xmlns:a16="http://schemas.microsoft.com/office/drawing/2014/main" id="{6753252F-4873-4F63-801D-CC719279A7D5}"/>
               </a:ext>
               <a:ext uri="{C183D7F6-B498-43B3-948B-1728B52AA6E4}">
                 <adec:decorative xmlns:adec="http://schemas.microsoft.com/office/drawing/2017/decorative" val="1"/>
@@ -7131,7 +7562,7 @@
           <p:cNvPr id="12" name="Rectangle 11">
             <a:extLst>
               <a:ext uri="{FF2B5EF4-FFF2-40B4-BE49-F238E27FC236}">
-                <a16:creationId xmlns:a16="http://schemas.microsoft.com/office/drawing/2014/main" id="{2FAEF9D4-216C-3035-594D-80BE1E08CBF4}"/>
+                <a16:creationId xmlns:a16="http://schemas.microsoft.com/office/drawing/2014/main" id="{047C8CCB-F95D-4249-92DD-651249D3535A}"/>
               </a:ext>
               <a:ext uri="{C183D7F6-B498-43B3-948B-1728B52AA6E4}">
                 <adec:decorative xmlns:adec="http://schemas.microsoft.com/office/drawing/2017/decorative" val="1"/>
@@ -7194,7 +7625,7 @@
           <p:cNvPr id="2" name="Title 1">
             <a:extLst>
               <a:ext uri="{FF2B5EF4-FFF2-40B4-BE49-F238E27FC236}">
-                <a16:creationId xmlns:a16="http://schemas.microsoft.com/office/drawing/2014/main" id="{EDCBE170-BE89-06EC-80D8-F8866FB3FBF6}"/>
+                <a16:creationId xmlns:a16="http://schemas.microsoft.com/office/drawing/2014/main" id="{18A6435D-C717-C4FD-EF2C-FA1D0C1D0CC6}"/>
               </a:ext>
             </a:extLst>
           </p:cNvPr>
@@ -7238,84 +7669,50 @@
                 <a:ea typeface="+mj-ea"/>
                 <a:cs typeface="+mj-cs"/>
               </a:rPr>
-              <a:t>BCA SEM</a:t>
-            </a:r>
-          </a:p>
-        </p:txBody>
-      </p:sp>
-      <p:sp>
-        <p:nvSpPr>
-          <p:cNvPr id="14" name="TextBox 13">
-            <a:extLst>
-              <a:ext uri="{FF2B5EF4-FFF2-40B4-BE49-F238E27FC236}">
-                <a16:creationId xmlns:a16="http://schemas.microsoft.com/office/drawing/2014/main" id="{AA18D2CF-5741-17E2-9D54-58A4BE4064A8}"/>
-              </a:ext>
-            </a:extLst>
-          </p:cNvPr>
-          <p:cNvSpPr txBox="1"/>
-          <p:nvPr/>
-        </p:nvSpPr>
+              <a:t>Workflow</a:t>
+            </a:r>
+          </a:p>
+        </p:txBody>
+      </p:sp>
+      <p:pic>
+        <p:nvPicPr>
+          <p:cNvPr id="7" name="Content Placeholder 6" descr="A diagram of a flowchart&#10;&#10;AI-generated content may be incorrect.">
+            <a:extLst>
+              <a:ext uri="{FF2B5EF4-FFF2-40B4-BE49-F238E27FC236}">
+                <a16:creationId xmlns:a16="http://schemas.microsoft.com/office/drawing/2014/main" id="{E69405CA-142F-F369-F592-CB4130B11C03}"/>
+              </a:ext>
+            </a:extLst>
+          </p:cNvPr>
+          <p:cNvPicPr>
+            <a:picLocks noGrp="1" noChangeAspect="1"/>
+          </p:cNvPicPr>
+          <p:nvPr>
+            <p:ph idx="1"/>
+          </p:nvPr>
+        </p:nvPicPr>
+        <p:blipFill>
+          <a:blip r:embed="rId3">
+            <a:extLst>
+              <a:ext uri="{28A0092B-C50C-407E-A947-70E740481C1C}">
+                <a14:useLocalDpi xmlns:a14="http://schemas.microsoft.com/office/drawing/2010/main" val="0"/>
+              </a:ext>
+            </a:extLst>
+          </a:blip>
+          <a:stretch>
+            <a:fillRect/>
+          </a:stretch>
+        </p:blipFill>
         <p:spPr>
           <a:xfrm>
-            <a:off x="4132161" y="2627453"/>
-            <a:ext cx="6875362" cy="1200329"/>
+            <a:off x="4032514" y="1371530"/>
+            <a:ext cx="6858232" cy="4114939"/>
           </a:xfrm>
-          <a:prstGeom prst="rect">
-            <a:avLst/>
-          </a:prstGeom>
-          <a:noFill/>
         </p:spPr>
-        <p:txBody>
-          <a:bodyPr wrap="square" rtlCol="0">
-            <a:spAutoFit/>
-          </a:bodyPr>
-          <a:lstStyle/>
-          <a:p>
-            <a:r>
-              <a:rPr lang="en-US" dirty="0"/>
-              <a:t>Step 1: Regress </a:t>
-            </a:r>
-            <a:r>
-              <a:rPr lang="en-US" dirty="0" err="1"/>
-              <a:t>X_t</a:t>
-            </a:r>
-            <a:r>
-              <a:rPr lang="en-US" dirty="0"/>
-              <a:t> (and </a:t>
-            </a:r>
-            <a:r>
-              <a:rPr lang="en-US" dirty="0" err="1"/>
-              <a:t>Y_t</a:t>
-            </a:r>
-            <a:r>
-              <a:rPr lang="en-US" dirty="0"/>
-              <a:t>) on C</a:t>
-            </a:r>
-          </a:p>
-          <a:p>
-            <a:r>
-              <a:rPr lang="en-US" dirty="0"/>
-              <a:t>Step 2: Save the residuals</a:t>
-            </a:r>
-          </a:p>
-          <a:p>
-            <a:r>
-              <a:rPr lang="en-US" dirty="0"/>
-              <a:t>Step 3: Do your standard CLPM</a:t>
-            </a:r>
-          </a:p>
-          <a:p>
-            <a:r>
-              <a:rPr lang="en-US" dirty="0"/>
-              <a:t>Step 4: Oops we should have bootstrapped to estimate our errors. </a:t>
-            </a:r>
-          </a:p>
-        </p:txBody>
-      </p:sp>
+      </p:pic>
     </p:spTree>
     <p:extLst>
       <p:ext uri="{BB962C8B-B14F-4D97-AF65-F5344CB8AC3E}">
-        <p14:creationId xmlns:p14="http://schemas.microsoft.com/office/powerpoint/2010/main" val="3220156857"/>
+        <p14:creationId xmlns:p14="http://schemas.microsoft.com/office/powerpoint/2010/main" val="1494431278"/>
       </p:ext>
     </p:extLst>
   </p:cSld>
@@ -7328,20 +7725,12 @@
 <file path=ppt/slides/slide5.xml><?xml version="1.0" encoding="utf-8"?>
 <p:sld xmlns:a="http://schemas.openxmlformats.org/drawingml/2006/main" xmlns:r="http://schemas.openxmlformats.org/officeDocument/2006/relationships" xmlns:p="http://schemas.openxmlformats.org/presentationml/2006/main">
   <p:cSld>
-    <p:bg>
-      <p:bgPr>
-        <a:solidFill>
-          <a:schemeClr val="bg1"/>
-        </a:solidFill>
-        <a:effectLst/>
-      </p:bgPr>
-    </p:bg>
     <p:spTree>
       <p:nvGrpSpPr>
         <p:cNvPr id="1" name="">
           <a:extLst>
             <a:ext uri="{FF2B5EF4-FFF2-40B4-BE49-F238E27FC236}">
-              <a16:creationId xmlns:a16="http://schemas.microsoft.com/office/drawing/2014/main" id="{F9C7C219-9DB4-DAD3-B98D-ED0FBBBC25C4}"/>
+              <a16:creationId xmlns:a16="http://schemas.microsoft.com/office/drawing/2014/main" id="{54D04B62-F15A-629A-70A9-C02C3E6066B7}"/>
             </a:ext>
           </a:extLst>
         </p:cNvPr>
@@ -7358,136 +7747,10 @@
       </p:grpSpPr>
       <p:sp>
         <p:nvSpPr>
-          <p:cNvPr id="10" name="Rectangle 9">
-            <a:extLst>
-              <a:ext uri="{FF2B5EF4-FFF2-40B4-BE49-F238E27FC236}">
-                <a16:creationId xmlns:a16="http://schemas.microsoft.com/office/drawing/2014/main" id="{6753252F-4873-4F63-801D-CC719279A7D5}"/>
-              </a:ext>
-              <a:ext uri="{C183D7F6-B498-43B3-948B-1728B52AA6E4}">
-                <adec:decorative xmlns:adec="http://schemas.microsoft.com/office/drawing/2017/decorative" val="1"/>
-              </a:ext>
-            </a:extLst>
-          </p:cNvPr>
-          <p:cNvSpPr>
-            <a:spLocks noGrp="1" noRot="1" noChangeAspect="1" noMove="1" noResize="1" noEditPoints="1" noAdjustHandles="1" noChangeArrowheads="1" noChangeShapeType="1" noTextEdit="1"/>
-          </p:cNvSpPr>
-          <p:nvPr>
-            <p:extLst>
-              <p:ext uri="{386F3935-93C4-4BCD-93E2-E3B085C9AB24}">
-                <p16:designElem xmlns:p16="http://schemas.microsoft.com/office/powerpoint/2015/main" val="1"/>
-              </p:ext>
-            </p:extLst>
-          </p:nvPr>
-        </p:nvSpPr>
-        <p:spPr>
-          <a:xfrm>
-            <a:off x="0" y="0"/>
-            <a:ext cx="12192000" cy="6858000"/>
-          </a:xfrm>
-          <a:prstGeom prst="rect">
-            <a:avLst/>
-          </a:prstGeom>
-          <a:solidFill>
-            <a:srgbClr val="FFFFFF"/>
-          </a:solidFill>
-          <a:ln>
-            <a:noFill/>
-          </a:ln>
-        </p:spPr>
-        <p:style>
-          <a:lnRef idx="2">
-            <a:schemeClr val="accent1">
-              <a:shade val="50000"/>
-            </a:schemeClr>
-          </a:lnRef>
-          <a:fillRef idx="1">
-            <a:schemeClr val="accent1"/>
-          </a:fillRef>
-          <a:effectRef idx="0">
-            <a:schemeClr val="accent1"/>
-          </a:effectRef>
-          <a:fontRef idx="minor">
-            <a:schemeClr val="lt1"/>
-          </a:fontRef>
-        </p:style>
-        <p:txBody>
-          <a:bodyPr rtlCol="0" anchor="ctr"/>
-          <a:lstStyle/>
-          <a:p>
-            <a:pPr algn="ctr"/>
-            <a:endParaRPr lang="en-US"/>
-          </a:p>
-        </p:txBody>
-      </p:sp>
-      <p:sp>
-        <p:nvSpPr>
-          <p:cNvPr id="12" name="Rectangle 11">
-            <a:extLst>
-              <a:ext uri="{FF2B5EF4-FFF2-40B4-BE49-F238E27FC236}">
-                <a16:creationId xmlns:a16="http://schemas.microsoft.com/office/drawing/2014/main" id="{047C8CCB-F95D-4249-92DD-651249D3535A}"/>
-              </a:ext>
-              <a:ext uri="{C183D7F6-B498-43B3-948B-1728B52AA6E4}">
-                <adec:decorative xmlns:adec="http://schemas.microsoft.com/office/drawing/2017/decorative" val="1"/>
-              </a:ext>
-            </a:extLst>
-          </p:cNvPr>
-          <p:cNvSpPr>
-            <a:spLocks noGrp="1" noRot="1" noChangeAspect="1" noMove="1" noResize="1" noEditPoints="1" noAdjustHandles="1" noChangeArrowheads="1" noChangeShapeType="1" noTextEdit="1"/>
-          </p:cNvSpPr>
-          <p:nvPr>
-            <p:extLst>
-              <p:ext uri="{386F3935-93C4-4BCD-93E2-E3B085C9AB24}">
-                <p16:designElem xmlns:p16="http://schemas.microsoft.com/office/powerpoint/2015/main" val="1"/>
-              </p:ext>
-            </p:extLst>
-          </p:nvPr>
-        </p:nvSpPr>
-        <p:spPr>
-          <a:xfrm>
-            <a:off x="0" y="0"/>
-            <a:ext cx="2013557" cy="6858000"/>
-          </a:xfrm>
-          <a:prstGeom prst="rect">
-            <a:avLst/>
-          </a:prstGeom>
-          <a:solidFill>
-            <a:srgbClr val="383B64"/>
-          </a:solidFill>
-          <a:ln>
-            <a:noFill/>
-          </a:ln>
-        </p:spPr>
-        <p:style>
-          <a:lnRef idx="2">
-            <a:schemeClr val="accent1">
-              <a:shade val="50000"/>
-            </a:schemeClr>
-          </a:lnRef>
-          <a:fillRef idx="1">
-            <a:schemeClr val="accent1"/>
-          </a:fillRef>
-          <a:effectRef idx="0">
-            <a:schemeClr val="accent1"/>
-          </a:effectRef>
-          <a:fontRef idx="minor">
-            <a:schemeClr val="lt1"/>
-          </a:fontRef>
-        </p:style>
-        <p:txBody>
-          <a:bodyPr rtlCol="0" anchor="ctr"/>
-          <a:lstStyle/>
-          <a:p>
-            <a:pPr algn="ctr"/>
-            <a:endParaRPr lang="en-US"/>
-          </a:p>
-        </p:txBody>
-      </p:sp>
-      <p:sp>
-        <p:nvSpPr>
           <p:cNvPr id="2" name="Title 1">
             <a:extLst>
               <a:ext uri="{FF2B5EF4-FFF2-40B4-BE49-F238E27FC236}">
-                <a16:creationId xmlns:a16="http://schemas.microsoft.com/office/drawing/2014/main" id="{18A6435D-C717-C4FD-EF2C-FA1D0C1D0CC6}"/>
+                <a16:creationId xmlns:a16="http://schemas.microsoft.com/office/drawing/2014/main" id="{5F2B91CE-DB76-2B81-303E-D8D438819E7B}"/>
               </a:ext>
             </a:extLst>
           </p:cNvPr>
@@ -7523,7 +7786,7 @@
           <a:p>
             <a:pPr algn="ctr"/>
             <a:r>
-              <a:rPr lang="en-US" sz="2600" kern="1200" dirty="0">
+              <a:rPr lang="en-US" sz="2600" kern="1200">
                 <a:solidFill>
                   <a:srgbClr val="FFFFFF"/>
                 </a:solidFill>
@@ -7531,17 +7794,17 @@
                 <a:ea typeface="+mj-ea"/>
                 <a:cs typeface="+mj-cs"/>
               </a:rPr>
-              <a:t>Workflow</a:t>
+              <a:t>Problem / RQ</a:t>
             </a:r>
           </a:p>
         </p:txBody>
       </p:sp>
       <p:pic>
         <p:nvPicPr>
-          <p:cNvPr id="7" name="Content Placeholder 6" descr="A diagram of a flowchart&#10;&#10;AI-generated content may be incorrect.">
-            <a:extLst>
-              <a:ext uri="{FF2B5EF4-FFF2-40B4-BE49-F238E27FC236}">
-                <a16:creationId xmlns:a16="http://schemas.microsoft.com/office/drawing/2014/main" id="{E69405CA-142F-F369-F592-CB4130B11C03}"/>
+          <p:cNvPr id="7" name="Content Placeholder 6" descr="A diagram of a mathematical model&#10;&#10;AI-generated content may be incorrect.">
+            <a:extLst>
+              <a:ext uri="{FF2B5EF4-FFF2-40B4-BE49-F238E27FC236}">
+                <a16:creationId xmlns:a16="http://schemas.microsoft.com/office/drawing/2014/main" id="{0A7985A9-B041-9119-612F-B29FCEFAD70E}"/>
               </a:ext>
             </a:extLst>
           </p:cNvPr>
@@ -7566,15 +7829,18 @@
         </p:blipFill>
         <p:spPr>
           <a:xfrm>
-            <a:off x="4032514" y="1371530"/>
-            <a:ext cx="6858232" cy="4114939"/>
+            <a:off x="4038600" y="1136067"/>
+            <a:ext cx="7188199" cy="4582476"/>
           </a:xfrm>
+          <a:prstGeom prst="rect">
+            <a:avLst/>
+          </a:prstGeom>
         </p:spPr>
       </p:pic>
     </p:spTree>
     <p:extLst>
       <p:ext uri="{BB962C8B-B14F-4D97-AF65-F5344CB8AC3E}">
-        <p14:creationId xmlns:p14="http://schemas.microsoft.com/office/powerpoint/2010/main" val="1494431278"/>
+        <p14:creationId xmlns:p14="http://schemas.microsoft.com/office/powerpoint/2010/main" val="2756246999"/>
       </p:ext>
     </p:extLst>
   </p:cSld>
@@ -7782,25 +8048,30 @@
           <a:p>
             <a:pPr algn="ctr"/>
             <a:r>
-              <a:rPr lang="en-US" sz="2600" kern="1200" dirty="0">
+              <a:rPr lang="en-US" sz="2600" dirty="0">
                 <a:solidFill>
                   <a:srgbClr val="FFFFFF"/>
                 </a:solidFill>
-                <a:latin typeface="+mj-lt"/>
-                <a:ea typeface="+mj-ea"/>
-                <a:cs typeface="+mj-cs"/>
               </a:rPr>
-              <a:t>Data</a:t>
-            </a:r>
+              <a:t>Linear data</a:t>
+            </a:r>
+            <a:endParaRPr lang="en-US" sz="2600" kern="1200" dirty="0">
+              <a:solidFill>
+                <a:srgbClr val="FFFFFF"/>
+              </a:solidFill>
+              <a:latin typeface="+mj-lt"/>
+              <a:ea typeface="+mj-ea"/>
+              <a:cs typeface="+mj-cs"/>
+            </a:endParaRPr>
           </a:p>
         </p:txBody>
       </p:sp>
       <p:pic>
         <p:nvPicPr>
-          <p:cNvPr id="6" name="Picture 5">
-            <a:extLst>
-              <a:ext uri="{FF2B5EF4-FFF2-40B4-BE49-F238E27FC236}">
-                <a16:creationId xmlns:a16="http://schemas.microsoft.com/office/drawing/2014/main" id="{EB846E7A-5F30-8D39-AD6E-62DD53626D28}"/>
+          <p:cNvPr id="4" name="Picture 3">
+            <a:extLst>
+              <a:ext uri="{FF2B5EF4-FFF2-40B4-BE49-F238E27FC236}">
+                <a16:creationId xmlns:a16="http://schemas.microsoft.com/office/drawing/2014/main" id="{75B700BA-45CD-D42E-0B03-7D27AFFC4F07}"/>
               </a:ext>
             </a:extLst>
           </p:cNvPr>
@@ -7817,109 +8088,14 @@
         </p:blipFill>
         <p:spPr>
           <a:xfrm>
-            <a:off x="3610577" y="1047750"/>
-            <a:ext cx="2933700" cy="4762500"/>
+            <a:off x="4969458" y="1524000"/>
+            <a:ext cx="3829050" cy="3810000"/>
           </a:xfrm>
           <a:prstGeom prst="rect">
             <a:avLst/>
           </a:prstGeom>
         </p:spPr>
       </p:pic>
-      <p:pic>
-        <p:nvPicPr>
-          <p:cNvPr id="9" name="Picture 8">
-            <a:extLst>
-              <a:ext uri="{FF2B5EF4-FFF2-40B4-BE49-F238E27FC236}">
-                <a16:creationId xmlns:a16="http://schemas.microsoft.com/office/drawing/2014/main" id="{98594767-9692-F179-44CE-09DA8FC5D600}"/>
-              </a:ext>
-            </a:extLst>
-          </p:cNvPr>
-          <p:cNvPicPr>
-            <a:picLocks noChangeAspect="1"/>
-          </p:cNvPicPr>
-          <p:nvPr/>
-        </p:nvPicPr>
-        <p:blipFill>
-          <a:blip r:embed="rId4"/>
-          <a:stretch>
-            <a:fillRect/>
-          </a:stretch>
-        </p:blipFill>
-        <p:spPr>
-          <a:xfrm>
-            <a:off x="6406979" y="1047750"/>
-            <a:ext cx="2933700" cy="4762500"/>
-          </a:xfrm>
-          <a:prstGeom prst="rect">
-            <a:avLst/>
-          </a:prstGeom>
-        </p:spPr>
-      </p:pic>
-      <p:pic>
-        <p:nvPicPr>
-          <p:cNvPr id="13" name="Picture 12">
-            <a:extLst>
-              <a:ext uri="{FF2B5EF4-FFF2-40B4-BE49-F238E27FC236}">
-                <a16:creationId xmlns:a16="http://schemas.microsoft.com/office/drawing/2014/main" id="{E7942AC7-9E74-8F53-2C07-AE99C81B296C}"/>
-              </a:ext>
-            </a:extLst>
-          </p:cNvPr>
-          <p:cNvPicPr>
-            <a:picLocks noChangeAspect="1"/>
-          </p:cNvPicPr>
-          <p:nvPr/>
-        </p:nvPicPr>
-        <p:blipFill>
-          <a:blip r:embed="rId5"/>
-          <a:stretch>
-            <a:fillRect/>
-          </a:stretch>
-        </p:blipFill>
-        <p:spPr>
-          <a:xfrm>
-            <a:off x="9203381" y="1047750"/>
-            <a:ext cx="2933700" cy="4762500"/>
-          </a:xfrm>
-          <a:prstGeom prst="rect">
-            <a:avLst/>
-          </a:prstGeom>
-        </p:spPr>
-      </p:pic>
-      <p:sp>
-        <p:nvSpPr>
-          <p:cNvPr id="14" name="TextBox 13">
-            <a:extLst>
-              <a:ext uri="{FF2B5EF4-FFF2-40B4-BE49-F238E27FC236}">
-                <a16:creationId xmlns:a16="http://schemas.microsoft.com/office/drawing/2014/main" id="{70B691E5-9F19-1007-9855-765C26CA3B8F}"/>
-              </a:ext>
-            </a:extLst>
-          </p:cNvPr>
-          <p:cNvSpPr txBox="1"/>
-          <p:nvPr/>
-        </p:nvSpPr>
-        <p:spPr>
-          <a:xfrm>
-            <a:off x="3483980" y="219919"/>
-            <a:ext cx="7685590" cy="369332"/>
-          </a:xfrm>
-          <a:prstGeom prst="rect">
-            <a:avLst/>
-          </a:prstGeom>
-          <a:noFill/>
-        </p:spPr>
-        <p:txBody>
-          <a:bodyPr wrap="square" rtlCol="0">
-            <a:spAutoFit/>
-          </a:bodyPr>
-          <a:lstStyle/>
-          <a:p>
-            <a:r>
-              <a:rPr lang="en-US" dirty="0"/>
-              <a:t>Number denotes: sum(nonlinear) / sum(nonlinear + linear)</a:t>
-            </a:r>
-          </a:p>
-        </p:txBody>
-      </p:sp>
     </p:spTree>
     <p:extLst>
       <p:ext uri="{BB962C8B-B14F-4D97-AF65-F5344CB8AC3E}">
@@ -8139,17 +8315,38 @@
                 <a:ea typeface="+mj-ea"/>
                 <a:cs typeface="+mj-cs"/>
               </a:rPr>
-              <a:t>Data</a:t>
+              <a:t>Data:</a:t>
+            </a:r>
+            <a:br>
+              <a:rPr lang="en-US" sz="2600" kern="1200" dirty="0">
+                <a:solidFill>
+                  <a:srgbClr val="FFFFFF"/>
+                </a:solidFill>
+                <a:latin typeface="+mj-lt"/>
+                <a:ea typeface="+mj-ea"/>
+                <a:cs typeface="+mj-cs"/>
+              </a:rPr>
+            </a:br>
+            <a:r>
+              <a:rPr lang="en-US" sz="2600" kern="1200" dirty="0">
+                <a:solidFill>
+                  <a:srgbClr val="FFFFFF"/>
+                </a:solidFill>
+                <a:latin typeface="+mj-lt"/>
+                <a:ea typeface="+mj-ea"/>
+                <a:cs typeface="+mj-cs"/>
+              </a:rPr>
+              <a:t>Cubic &amp; Cutoff</a:t>
             </a:r>
           </a:p>
         </p:txBody>
       </p:sp>
       <p:pic>
         <p:nvPicPr>
-          <p:cNvPr id="4" name="Picture 3">
-            <a:extLst>
-              <a:ext uri="{FF2B5EF4-FFF2-40B4-BE49-F238E27FC236}">
-                <a16:creationId xmlns:a16="http://schemas.microsoft.com/office/drawing/2014/main" id="{DE37C3AA-F9D2-4150-87D1-39450CD95DB7}"/>
+          <p:cNvPr id="5" name="Picture 4">
+            <a:extLst>
+              <a:ext uri="{FF2B5EF4-FFF2-40B4-BE49-F238E27FC236}">
+                <a16:creationId xmlns:a16="http://schemas.microsoft.com/office/drawing/2014/main" id="{84792CFC-3E4A-49FA-C531-B7AE9F2F9065}"/>
               </a:ext>
             </a:extLst>
           </p:cNvPr>
@@ -8166,8 +8363,8 @@
         </p:blipFill>
         <p:spPr>
           <a:xfrm>
-            <a:off x="4305059" y="1047750"/>
-            <a:ext cx="2933700" cy="4762500"/>
+            <a:off x="7528619" y="1943783"/>
+            <a:ext cx="4395658" cy="3280342"/>
           </a:xfrm>
           <a:prstGeom prst="rect">
             <a:avLst/>
@@ -8176,10 +8373,10 @@
       </p:pic>
       <p:pic>
         <p:nvPicPr>
-          <p:cNvPr id="7" name="Picture 6">
-            <a:extLst>
-              <a:ext uri="{FF2B5EF4-FFF2-40B4-BE49-F238E27FC236}">
-                <a16:creationId xmlns:a16="http://schemas.microsoft.com/office/drawing/2014/main" id="{61952D98-6344-BCE7-E584-C5130939CAEE}"/>
+          <p:cNvPr id="8" name="Picture 7">
+            <a:extLst>
+              <a:ext uri="{FF2B5EF4-FFF2-40B4-BE49-F238E27FC236}">
+                <a16:creationId xmlns:a16="http://schemas.microsoft.com/office/drawing/2014/main" id="{14B97073-C468-4E43-B71D-3E1F4730FEC8}"/>
               </a:ext>
             </a:extLst>
           </p:cNvPr>
@@ -8196,8 +8393,8 @@
         </p:blipFill>
         <p:spPr>
           <a:xfrm>
-            <a:off x="7511246" y="1047750"/>
-            <a:ext cx="2933700" cy="4762500"/>
+            <a:off x="3573622" y="1943783"/>
+            <a:ext cx="4395656" cy="3280341"/>
           </a:xfrm>
           <a:prstGeom prst="rect">
             <a:avLst/>
@@ -8233,7 +8430,7 @@
         <p:cNvPr id="1" name="">
           <a:extLst>
             <a:ext uri="{FF2B5EF4-FFF2-40B4-BE49-F238E27FC236}">
-              <a16:creationId xmlns:a16="http://schemas.microsoft.com/office/drawing/2014/main" id="{2FBFD045-7D9D-6CE9-F353-546B188816AC}"/>
+              <a16:creationId xmlns:a16="http://schemas.microsoft.com/office/drawing/2014/main" id="{B3C10927-0BFA-DA15-D890-7D384E504CA4}"/>
             </a:ext>
           </a:extLst>
         </p:cNvPr>
@@ -8250,10 +8447,10 @@
       </p:grpSpPr>
       <p:sp>
         <p:nvSpPr>
-          <p:cNvPr id="12" name="Rectangle 11">
-            <a:extLst>
-              <a:ext uri="{FF2B5EF4-FFF2-40B4-BE49-F238E27FC236}">
-                <a16:creationId xmlns:a16="http://schemas.microsoft.com/office/drawing/2014/main" id="{6753252F-4873-4F63-801D-CC719279A7D5}"/>
+          <p:cNvPr id="10" name="Rectangle 9">
+            <a:extLst>
+              <a:ext uri="{FF2B5EF4-FFF2-40B4-BE49-F238E27FC236}">
+                <a16:creationId xmlns:a16="http://schemas.microsoft.com/office/drawing/2014/main" id="{9D8EA10F-5CA6-DB6D-8844-14E04B451546}"/>
               </a:ext>
               <a:ext uri="{C183D7F6-B498-43B3-948B-1728B52AA6E4}">
                 <adec:decorative xmlns:adec="http://schemas.microsoft.com/office/drawing/2017/decorative" val="1"/>
@@ -8313,10 +8510,10 @@
       </p:sp>
       <p:sp>
         <p:nvSpPr>
-          <p:cNvPr id="14" name="Rectangle 13">
-            <a:extLst>
-              <a:ext uri="{FF2B5EF4-FFF2-40B4-BE49-F238E27FC236}">
-                <a16:creationId xmlns:a16="http://schemas.microsoft.com/office/drawing/2014/main" id="{047C8CCB-F95D-4249-92DD-651249D3535A}"/>
+          <p:cNvPr id="12" name="Rectangle 11">
+            <a:extLst>
+              <a:ext uri="{FF2B5EF4-FFF2-40B4-BE49-F238E27FC236}">
+                <a16:creationId xmlns:a16="http://schemas.microsoft.com/office/drawing/2014/main" id="{D679FA8D-FD45-025C-9D7B-21E4794263E4}"/>
               </a:ext>
               <a:ext uri="{C183D7F6-B498-43B3-948B-1728B52AA6E4}">
                 <adec:decorative xmlns:adec="http://schemas.microsoft.com/office/drawing/2017/decorative" val="1"/>
@@ -8343,7 +8540,7 @@
             <a:avLst/>
           </a:prstGeom>
           <a:solidFill>
-            <a:srgbClr val="303250"/>
+            <a:srgbClr val="383B64"/>
           </a:solidFill>
           <a:ln>
             <a:noFill/>
@@ -8379,7 +8576,7 @@
           <p:cNvPr id="2" name="Title 1">
             <a:extLst>
               <a:ext uri="{FF2B5EF4-FFF2-40B4-BE49-F238E27FC236}">
-                <a16:creationId xmlns:a16="http://schemas.microsoft.com/office/drawing/2014/main" id="{1D039B5E-3D15-38D8-3DEA-C0268F4911F5}"/>
+                <a16:creationId xmlns:a16="http://schemas.microsoft.com/office/drawing/2014/main" id="{1C976478-D98E-B1E9-47CE-A42B3D5030E4}"/>
               </a:ext>
             </a:extLst>
           </p:cNvPr>
@@ -8423,43 +8620,118 @@
                 <a:ea typeface="+mj-ea"/>
                 <a:cs typeface="+mj-cs"/>
               </a:rPr>
-              <a:t>Data</a:t>
-            </a:r>
+              <a:t>Data:</a:t>
+            </a:r>
+            <a:br>
+              <a:rPr lang="en-US" sz="2600" dirty="0">
+                <a:solidFill>
+                  <a:srgbClr val="FFFFFF"/>
+                </a:solidFill>
+              </a:rPr>
+            </a:br>
+            <a:r>
+              <a:rPr lang="en-US" sz="2600" dirty="0">
+                <a:solidFill>
+                  <a:srgbClr val="FFFFFF"/>
+                </a:solidFill>
+              </a:rPr>
+              <a:t>Exponential</a:t>
+            </a:r>
+            <a:br>
+              <a:rPr lang="en-US" sz="2600" dirty="0">
+                <a:solidFill>
+                  <a:srgbClr val="FFFFFF"/>
+                </a:solidFill>
+              </a:rPr>
+            </a:br>
+            <a:r>
+              <a:rPr lang="en-US" sz="2600" dirty="0">
+                <a:solidFill>
+                  <a:srgbClr val="FFFFFF"/>
+                </a:solidFill>
+              </a:rPr>
+              <a:t>&amp;</a:t>
+            </a:r>
+            <a:br>
+              <a:rPr lang="en-US" sz="2600" dirty="0">
+                <a:solidFill>
+                  <a:srgbClr val="FFFFFF"/>
+                </a:solidFill>
+              </a:rPr>
+            </a:br>
+            <a:r>
+              <a:rPr lang="en-US" sz="2600" dirty="0">
+                <a:solidFill>
+                  <a:srgbClr val="FFFFFF"/>
+                </a:solidFill>
+              </a:rPr>
+              <a:t>Sin</a:t>
+            </a:r>
+            <a:endParaRPr lang="en-US" sz="2600" kern="1200" dirty="0">
+              <a:solidFill>
+                <a:srgbClr val="FFFFFF"/>
+              </a:solidFill>
+              <a:latin typeface="+mj-lt"/>
+              <a:ea typeface="+mj-ea"/>
+              <a:cs typeface="+mj-cs"/>
+            </a:endParaRPr>
           </a:p>
         </p:txBody>
       </p:sp>
       <p:pic>
         <p:nvPicPr>
-          <p:cNvPr id="7" name="Content Placeholder 6" descr="A diagram of a mathematical model&#10;&#10;AI-generated content may be incorrect.">
-            <a:extLst>
-              <a:ext uri="{FF2B5EF4-FFF2-40B4-BE49-F238E27FC236}">
-                <a16:creationId xmlns:a16="http://schemas.microsoft.com/office/drawing/2014/main" id="{059F9E62-7456-DD79-716E-3D141B5B95C9}"/>
+          <p:cNvPr id="7" name="Picture 6">
+            <a:extLst>
+              <a:ext uri="{FF2B5EF4-FFF2-40B4-BE49-F238E27FC236}">
+                <a16:creationId xmlns:a16="http://schemas.microsoft.com/office/drawing/2014/main" id="{AD8A368F-3364-3EFA-87CE-8D41F0C276E7}"/>
               </a:ext>
             </a:extLst>
           </p:cNvPr>
           <p:cNvPicPr>
-            <a:picLocks noGrp="1" noChangeAspect="1"/>
+            <a:picLocks noChangeAspect="1"/>
           </p:cNvPicPr>
-          <p:nvPr>
-            <p:ph idx="1"/>
-          </p:nvPr>
+          <p:nvPr/>
         </p:nvPicPr>
         <p:blipFill>
-          <a:blip r:embed="rId3">
-            <a:extLst>
-              <a:ext uri="{28A0092B-C50C-407E-A947-70E740481C1C}">
-                <a14:useLocalDpi xmlns:a14="http://schemas.microsoft.com/office/drawing/2010/main" val="0"/>
-              </a:ext>
-            </a:extLst>
-          </a:blip>
+          <a:blip r:embed="rId3"/>
           <a:stretch>
             <a:fillRect/>
           </a:stretch>
         </p:blipFill>
         <p:spPr>
           <a:xfrm>
-            <a:off x="4038600" y="1136067"/>
-            <a:ext cx="7188199" cy="4582476"/>
+            <a:off x="3450018" y="1927405"/>
+            <a:ext cx="4024273" cy="3003189"/>
+          </a:xfrm>
+          <a:prstGeom prst="rect">
+            <a:avLst/>
+          </a:prstGeom>
+        </p:spPr>
+      </p:pic>
+      <p:pic>
+        <p:nvPicPr>
+          <p:cNvPr id="9" name="Picture 8">
+            <a:extLst>
+              <a:ext uri="{FF2B5EF4-FFF2-40B4-BE49-F238E27FC236}">
+                <a16:creationId xmlns:a16="http://schemas.microsoft.com/office/drawing/2014/main" id="{52AAD7A1-83F4-3CE1-BECA-935458A66A25}"/>
+              </a:ext>
+            </a:extLst>
+          </p:cNvPr>
+          <p:cNvPicPr>
+            <a:picLocks noChangeAspect="1"/>
+          </p:cNvPicPr>
+          <p:nvPr/>
+        </p:nvPicPr>
+        <p:blipFill>
+          <a:blip r:embed="rId4"/>
+          <a:stretch>
+            <a:fillRect/>
+          </a:stretch>
+        </p:blipFill>
+        <p:spPr>
+          <a:xfrm>
+            <a:off x="7420934" y="1960430"/>
+            <a:ext cx="4077629" cy="3043007"/>
           </a:xfrm>
           <a:prstGeom prst="rect">
             <a:avLst/>
@@ -8469,7 +8741,7 @@
     </p:spTree>
     <p:extLst>
       <p:ext uri="{BB962C8B-B14F-4D97-AF65-F5344CB8AC3E}">
-        <p14:creationId xmlns:p14="http://schemas.microsoft.com/office/powerpoint/2010/main" val="1458030042"/>
+        <p14:creationId xmlns:p14="http://schemas.microsoft.com/office/powerpoint/2010/main" val="1789081059"/>
       </p:ext>
     </p:extLst>
   </p:cSld>
@@ -8495,7 +8767,7 @@
         <p:cNvPr id="1" name="">
           <a:extLst>
             <a:ext uri="{FF2B5EF4-FFF2-40B4-BE49-F238E27FC236}">
-              <a16:creationId xmlns:a16="http://schemas.microsoft.com/office/drawing/2014/main" id="{4E70D5D5-9C56-230B-329D-DFD5F55681F3}"/>
+              <a16:creationId xmlns:a16="http://schemas.microsoft.com/office/drawing/2014/main" id="{44C8CB9A-2305-C78F-E863-C9D337082C23}"/>
             </a:ext>
           </a:extLst>
         </p:cNvPr>
@@ -8515,7 +8787,7 @@
           <p:cNvPr id="10" name="Rectangle 9">
             <a:extLst>
               <a:ext uri="{FF2B5EF4-FFF2-40B4-BE49-F238E27FC236}">
-                <a16:creationId xmlns:a16="http://schemas.microsoft.com/office/drawing/2014/main" id="{27AB6FD3-FA5D-38FB-B381-28A41D080A17}"/>
+                <a16:creationId xmlns:a16="http://schemas.microsoft.com/office/drawing/2014/main" id="{2DCBAFF9-7D2A-64BA-6D53-6100E3D1592D}"/>
               </a:ext>
               <a:ext uri="{C183D7F6-B498-43B3-948B-1728B52AA6E4}">
                 <adec:decorative xmlns:adec="http://schemas.microsoft.com/office/drawing/2017/decorative" val="1"/>
@@ -8578,7 +8850,7 @@
           <p:cNvPr id="12" name="Rectangle 11">
             <a:extLst>
               <a:ext uri="{FF2B5EF4-FFF2-40B4-BE49-F238E27FC236}">
-                <a16:creationId xmlns:a16="http://schemas.microsoft.com/office/drawing/2014/main" id="{D12682AF-82BF-2486-D716-B7A49E86ED75}"/>
+                <a16:creationId xmlns:a16="http://schemas.microsoft.com/office/drawing/2014/main" id="{D50C80EA-5D70-9BF0-E648-9F2D3A1BB241}"/>
               </a:ext>
               <a:ext uri="{C183D7F6-B498-43B3-948B-1728B52AA6E4}">
                 <adec:decorative xmlns:adec="http://schemas.microsoft.com/office/drawing/2017/decorative" val="1"/>
@@ -8641,7 +8913,7 @@
           <p:cNvPr id="2" name="Title 1">
             <a:extLst>
               <a:ext uri="{FF2B5EF4-FFF2-40B4-BE49-F238E27FC236}">
-                <a16:creationId xmlns:a16="http://schemas.microsoft.com/office/drawing/2014/main" id="{5E3070DB-C71B-F001-EF5B-8357FEC216D6}"/>
+                <a16:creationId xmlns:a16="http://schemas.microsoft.com/office/drawing/2014/main" id="{8CBAABF7-8BCE-35C3-D5A5-1FAAF1DE2FD2}"/>
               </a:ext>
             </a:extLst>
           </p:cNvPr>
@@ -8677,12 +8949,30 @@
           <a:p>
             <a:pPr algn="ctr"/>
             <a:r>
+              <a:rPr lang="en-US" sz="2600" kern="1200" dirty="0">
+                <a:solidFill>
+                  <a:srgbClr val="FFFFFF"/>
+                </a:solidFill>
+                <a:latin typeface="+mj-lt"/>
+                <a:ea typeface="+mj-ea"/>
+                <a:cs typeface="+mj-cs"/>
+              </a:rPr>
+              <a:t>Data:</a:t>
+            </a:r>
+            <a:br>
               <a:rPr lang="en-US" sz="2600" dirty="0">
                 <a:solidFill>
                   <a:srgbClr val="FFFFFF"/>
                 </a:solidFill>
               </a:rPr>
-              <a:t>Models</a:t>
+            </a:br>
+            <a:r>
+              <a:rPr lang="en-US" sz="2600" dirty="0">
+                <a:solidFill>
+                  <a:srgbClr val="FFFFFF"/>
+                </a:solidFill>
+              </a:rPr>
+              <a:t>tanh</a:t>
             </a:r>
             <a:endParaRPr lang="en-US" sz="2600" kern="1200" dirty="0">
               <a:solidFill>
@@ -8697,10 +8987,10 @@
       </p:sp>
       <p:pic>
         <p:nvPicPr>
-          <p:cNvPr id="5" name="Picture 4">
-            <a:extLst>
-              <a:ext uri="{FF2B5EF4-FFF2-40B4-BE49-F238E27FC236}">
-                <a16:creationId xmlns:a16="http://schemas.microsoft.com/office/drawing/2014/main" id="{41911BC0-664E-FF37-F6A5-C615AB65FADD}"/>
+          <p:cNvPr id="4" name="Picture 3">
+            <a:extLst>
+              <a:ext uri="{FF2B5EF4-FFF2-40B4-BE49-F238E27FC236}">
+                <a16:creationId xmlns:a16="http://schemas.microsoft.com/office/drawing/2014/main" id="{6F1EE464-4800-3E77-F6C4-1AA3B2827D21}"/>
               </a:ext>
             </a:extLst>
           </p:cNvPr>
@@ -8717,8 +9007,8 @@
         </p:blipFill>
         <p:spPr>
           <a:xfrm>
-            <a:off x="4181134" y="1244263"/>
-            <a:ext cx="6828331" cy="4572543"/>
+            <a:off x="5075758" y="1703845"/>
+            <a:ext cx="4623414" cy="3450309"/>
           </a:xfrm>
           <a:prstGeom prst="rect">
             <a:avLst/>
@@ -8728,7 +9018,7 @@
     </p:spTree>
     <p:extLst>
       <p:ext uri="{BB962C8B-B14F-4D97-AF65-F5344CB8AC3E}">
-        <p14:creationId xmlns:p14="http://schemas.microsoft.com/office/powerpoint/2010/main" val="1163571441"/>
+        <p14:creationId xmlns:p14="http://schemas.microsoft.com/office/powerpoint/2010/main" val="1148546594"/>
       </p:ext>
     </p:extLst>
   </p:cSld>

</xml_diff>